<commit_message>
Documentación de InfoReport, ejemplos actualizados y ajustes finales
- README, LEEME y validación describen los cuatro ámbitos, los tres niveles
  territoriales, el nivel de los reportes y los productos actuales.
- Procedencia de la cartografía INEC 2015 con la licencia MIT de ec-atlas.
- Ejemplos regenerados: resúmenes de transferencias, servicios, presupuesto
  y gestión laboral, presentación y libro de datos.
- Indicador y nivel territorial apilados sobre el mapa (caben tres
  indicadores en servicios y en los años de referencia).
- Tablas parroquiales seis veces más rápidas.

Co-Authored-By: Claude Opus 5.5 <noreply@anthropic.com>
Claude-Session: https://claude.ai/code/session_01AUCWMWZ6GMzdHUXxvK5iGa
</commit_message>
<xml_diff>
--- a/examples/Presentacion_transferencias_2026-09.pptx
+++ b/examples/Presentacion_transferencias_2026-09.pptx
@@ -8,6 +8,9 @@
     <p:sldId id="256" r:id="rId7"/>
     <p:sldId id="257" r:id="rId9"/>
     <p:sldId id="258" r:id="rId10"/>
+    <p:sldId id="259" r:id="rId11"/>
+    <p:sldId id="260" r:id="rId12"/>
+    <p:sldId id="261" r:id="rId13"/>
   </p:sldIdLst>
   <p:sldSz cx="12191695" cy="6858000" type="screen4x3"/>
   <p:notesSz cx="6858000" cy="9144000"/>
@@ -127,6 +130,185 @@
               <c:strCache>
                 <c:ptCount val="1"/>
                 <c:pt idx="0">
+                  <c:v>Ejecución presupuestaria</c:v>
+                </c:pt>
+              </c:strCache>
+            </c:strRef>
+          </c:tx>
+          <c:spPr>
+            <a:solidFill>
+              <a:srgbClr val="5A369A"/>
+            </a:solidFill>
+          </c:spPr>
+          <c:cat>
+            <c:strRef>
+              <c:f>Sheet1!$A$2:$A$7</c:f>
+              <c:strCache>
+                <c:ptCount val="6"/>
+                <c:pt idx="0">
+                  <c:v>Pensión Toda Una Vida</c:v>
+                </c:pt>
+                <c:pt idx="1">
+                  <c:v>Bono 1.000 Días</c:v>
+                </c:pt>
+                <c:pt idx="2">
+                  <c:v>Bono Joaquín Gallegos Lara</c:v>
+                </c:pt>
+                <c:pt idx="3">
+                  <c:v>BDH con componente variable</c:v>
+                </c:pt>
+                <c:pt idx="4">
+                  <c:v>Pensión Mis Mejores Años</c:v>
+                </c:pt>
+                <c:pt idx="5">
+                  <c:v>Bono de Desarrollo Humano</c:v>
+                </c:pt>
+              </c:strCache>
+            </c:strRef>
+          </c:cat>
+          <c:val>
+            <c:numRef>
+              <c:f>Sheet1!$B$2:$B$7</c:f>
+              <c:numCache>
+                <c:formatCode>0.0%</c:formatCode>
+                <c:ptCount val="6"/>
+                <c:pt idx="0">
+                  <c:v>0.7364827802404053</c:v>
+                </c:pt>
+                <c:pt idx="1">
+                  <c:v>0.704368918958513</c:v>
+                </c:pt>
+                <c:pt idx="2">
+                  <c:v>0.7418790029486376</c:v>
+                </c:pt>
+                <c:pt idx="3">
+                  <c:v>0.6756937654915233</c:v>
+                </c:pt>
+                <c:pt idx="4">
+                  <c:v>0.7261294187524969</c:v>
+                </c:pt>
+                <c:pt idx="5">
+                  <c:v>0.7093833023514423</c:v>
+                </c:pt>
+              </c:numCache>
+            </c:numRef>
+          </c:val>
+        </c:ser>
+        <c:dLbls>
+          <c:numFmt formatCode="0.0%" sourceLinked="0"/>
+          <c:txPr>
+            <a:bodyPr/>
+            <a:lstStyle/>
+            <a:p>
+              <a:pPr>
+                <a:defRPr sz="1200" b="1">
+                  <a:solidFill>
+                    <a:srgbClr val="20202B"/>
+                  </a:solidFill>
+                </a:defRPr>
+              </a:pPr>
+            </a:p>
+          </c:txPr>
+          <c:dLblPos val="outEnd"/>
+          <c:showLegendKey val="0"/>
+          <c:showVal val="1"/>
+          <c:showCatName val="0"/>
+          <c:showSerName val="0"/>
+          <c:showPercent val="0"/>
+          <c:showBubbleSize val="0"/>
+          <c:showLeaderLines val="1"/>
+        </c:dLbls>
+        <c:gapWidth val="70"/>
+        <c:axId val="-2068027336"/>
+        <c:axId val="-2113994440"/>
+      </c:barChart>
+      <c:catAx>
+        <c:axId val="-2068027336"/>
+        <c:scaling>
+          <c:orientation val="minMax"/>
+        </c:scaling>
+        <c:delete val="0"/>
+        <c:axPos val="l"/>
+        <c:majorTickMark val="out"/>
+        <c:minorTickMark val="none"/>
+        <c:tickLblPos val="nextTo"/>
+        <c:spPr>
+          <a:ln>
+            <a:noFill/>
+          </a:ln>
+        </c:spPr>
+        <c:txPr>
+          <a:bodyPr/>
+          <a:lstStyle/>
+          <a:p>
+            <a:pPr>
+              <a:defRPr sz="1200"/>
+            </a:pPr>
+          </a:p>
+        </c:txPr>
+        <c:crossAx val="-2113994440"/>
+        <c:crosses val="autoZero"/>
+        <c:auto val="1"/>
+        <c:lblAlgn val="ctr"/>
+        <c:lblOffset val="100"/>
+        <c:noMultiLvlLbl val="0"/>
+      </c:catAx>
+      <c:valAx>
+        <c:axId val="-2113994440"/>
+        <c:scaling>
+          <c:max val="1.0"/>
+          <c:min val="0.0"/>
+        </c:scaling>
+        <c:delete/>
+        <c:axPos val="b"/>
+        <c:majorTickMark val="out"/>
+        <c:minorTickMark val="none"/>
+        <c:tickLblPos val="nextTo"/>
+        <c:crossAx val="-2068027336"/>
+        <c:crosses val="autoZero"/>
+      </c:valAx>
+    </c:plotArea>
+    <c:dispBlanksAs val="gap"/>
+  </c:chart>
+  <c:txPr>
+    <a:bodyPr/>
+    <a:lstStyle/>
+    <a:p>
+      <a:pPr>
+        <a:defRPr sz="1200">
+          <a:solidFill>
+            <a:srgbClr val="20202B"/>
+          </a:solidFill>
+          <a:latin typeface="Calibri"/>
+        </a:defRPr>
+      </a:pPr>
+      <a:endParaRPr lang="en-US"/>
+    </a:p>
+  </c:txPr>
+  <c:externalData r:id="rId1">
+    <c:autoUpdate val="0"/>
+  </c:externalData>
+</c:chartSpace>
+</file>
+
+<file path=ppt/charts/chart2.xml><?xml version="1.0" encoding="utf-8"?>
+<c:chartSpace xmlns:c="http://schemas.openxmlformats.org/drawingml/2006/chart" xmlns:a="http://schemas.openxmlformats.org/drawingml/2006/main" xmlns:r="http://schemas.openxmlformats.org/officeDocument/2006/relationships">
+  <c:date1904 val="0"/>
+  <c:chart>
+    <c:autoTitleDeleted val="1"/>
+    <c:plotArea>
+      <c:barChart>
+        <c:barDir val="bar"/>
+        <c:grouping val="clustered"/>
+        <c:ser>
+          <c:idx val="0"/>
+          <c:order val="0"/>
+          <c:tx>
+            <c:strRef>
+              <c:f>Sheet1!$B$1</c:f>
+              <c:strCache>
+                <c:ptCount val="1"/>
+                <c:pt idx="0">
                   <c:v>Beneficiarios</c:v>
                 </c:pt>
               </c:strCache>
@@ -139,31 +321,25 @@
           </c:spPr>
           <c:cat>
             <c:strRef>
-              <c:f>Sheet1!$A$2:$A$9</c:f>
+              <c:f>Sheet1!$A$2:$A$7</c:f>
               <c:strCache>
-                <c:ptCount val="8"/>
+                <c:ptCount val="6"/>
                 <c:pt idx="0">
-                  <c:v>Pensión Discapacidad</c:v>
+                  <c:v>Bono Joaquín Gallegos Lara</c:v>
                 </c:pt>
                 <c:pt idx="1">
-                  <c:v>Pensión Adultos Mayores</c:v>
+                  <c:v>Pensión Toda Una Vida</c:v>
                 </c:pt>
                 <c:pt idx="2">
-                  <c:v>Bono Joaquín Gallegos Lara</c:v>
+                  <c:v>Bono 1.000 Días</c:v>
                 </c:pt>
                 <c:pt idx="3">
-                  <c:v>Pensión Toda Una Vida</c:v>
+                  <c:v>Pensión Mis Mejores Años</c:v>
                 </c:pt>
                 <c:pt idx="4">
-                  <c:v>Bono 1.000 Días</c:v>
+                  <c:v>BDH con componente variable</c:v>
                 </c:pt>
                 <c:pt idx="5">
-                  <c:v>Pensión Mis Mejores Años</c:v>
-                </c:pt>
-                <c:pt idx="6">
-                  <c:v>BDH con componente variable</c:v>
-                </c:pt>
-                <c:pt idx="7">
                   <c:v>Bono de Desarrollo Humano</c:v>
                 </c:pt>
               </c:strCache>
@@ -171,32 +347,26 @@
           </c:cat>
           <c:val>
             <c:numRef>
-              <c:f>Sheet1!$B$2:$B$9</c:f>
+              <c:f>Sheet1!$B$2:$B$7</c:f>
               <c:numCache>
                 <c:formatCode>#,##0</c:formatCode>
-                <c:ptCount val="8"/>
+                <c:ptCount val="6"/>
                 <c:pt idx="0">
-                  <c:v>0</c:v>
+                  <c:v>50129</c:v>
                 </c:pt>
                 <c:pt idx="1">
-                  <c:v>0</c:v>
+                  <c:v>72700</c:v>
                 </c:pt>
                 <c:pt idx="2">
-                  <c:v>50129</c:v>
+                  <c:v>164983</c:v>
                 </c:pt>
                 <c:pt idx="3">
-                  <c:v>72700</c:v>
+                  <c:v>303845</c:v>
                 </c:pt>
                 <c:pt idx="4">
-                  <c:v>164983</c:v>
+                  <c:v>367289</c:v>
                 </c:pt>
                 <c:pt idx="5">
-                  <c:v>303845</c:v>
-                </c:pt>
-                <c:pt idx="6">
-                  <c:v>367289</c:v>
-                </c:pt>
-                <c:pt idx="7">
                   <c:v>619073</c:v>
                 </c:pt>
               </c:numCache>
@@ -694,7 +864,7 @@
           <a:lstStyle/>
           <a:p>
             <a:r>
-              <a:t>Beneficiarios: 1.578.019. Programas con beneficiarios: 6. Presupuesto 2026: USD 1.011,2 M. Presupuesto acumulado 2023–2026: USD 3.759,0 M. Bono de Desarrollo Humano concentra el 39,2 % de los beneficiarios, con 619.073 personas.</a:t>
+              <a:t>Beneficiarios: 1.578.019. Ejecución presupuestaria: 71,0 %. Presupuesto ejecutado 2026: USD 1.011,2 M. Presupuesto acumulado 2023–2026: USD 3.759,0 M. Bono de Desarrollo Humano concentra el 39,2 % de los beneficiarios, con 619.073 personas.</a:t>
             </a:r>
           </a:p>
         </p:txBody>
@@ -834,7 +1004,217 @@
           <a:lstStyle/>
           <a:p>
             <a:r>
-              <a:t>Bono de Desarrollo Humano concentra el 39,2 % de los beneficiarios, con 619.073 personas. El presupuesto 2026 asciende a USD 1.011,2 millones y el presupuesto acumulado 2023–2026 alcanza USD 3.759,0 millones. Bono de Desarrollo Humano recibe el 26,7 % del presupuesto 2026, con USD 270,2 millones.</a:t>
+              <a:t>La mitad de los beneficiarios se concentra en 31 de los 223 cantones con cobertura.</a:t>
+            </a:r>
+          </a:p>
+        </p:txBody>
+      </p:sp>
+      <p:sp>
+        <p:nvSpPr>
+          <p:cNvPr id="4" name="Slide Number Placeholder 3"/>
+          <p:cNvSpPr>
+            <a:spLocks noGrp="1"/>
+          </p:cNvSpPr>
+          <p:nvPr>
+            <p:ph type="sldNum" idx="5" sz="quarter"/>
+          </p:nvPr>
+        </p:nvSpPr>
+        <p:spPr/>
+      </p:sp>
+    </p:spTree>
+  </p:cSld>
+  <p:clrMapOvr>
+    <a:masterClrMapping/>
+  </p:clrMapOvr>
+</p:notes>
+</file>
+
+<file path=ppt/notesSlides/notesSlide4.xml><?xml version="1.0" encoding="utf-8"?>
+<p:notes xmlns:a="http://schemas.openxmlformats.org/drawingml/2006/main" xmlns:p="http://schemas.openxmlformats.org/presentationml/2006/main" xmlns:r="http://schemas.openxmlformats.org/officeDocument/2006/relationships">
+  <p:cSld>
+    <p:spTree>
+      <p:nvGrpSpPr>
+        <p:cNvPr id="1" name=""/>
+        <p:cNvGrpSpPr/>
+        <p:nvPr/>
+      </p:nvGrpSpPr>
+      <p:grpSpPr>
+        <a:xfrm>
+          <a:off x="0" y="0"/>
+          <a:ext cx="0" cy="0"/>
+          <a:chOff x="0" y="0"/>
+          <a:chExt cx="0" cy="0"/>
+        </a:xfrm>
+      </p:grpSpPr>
+      <p:sp>
+        <p:nvSpPr>
+          <p:cNvPr id="2" name="Slide Image Placeholder 1"/>
+          <p:cNvSpPr>
+            <a:spLocks noGrp="1"/>
+          </p:cNvSpPr>
+          <p:nvPr>
+            <p:ph type="sldImg" idx="2"/>
+          </p:nvPr>
+        </p:nvSpPr>
+        <p:spPr/>
+      </p:sp>
+      <p:sp>
+        <p:nvSpPr>
+          <p:cNvPr id="3" name="Notes Placeholder 2"/>
+          <p:cNvSpPr>
+            <a:spLocks noGrp="1"/>
+          </p:cNvSpPr>
+          <p:nvPr>
+            <p:ph type="body" idx="3" sz="quarter"/>
+          </p:nvPr>
+        </p:nvSpPr>
+        <p:spPr/>
+        <p:txBody>
+          <a:bodyPr/>
+          <a:lstStyle/>
+          <a:p>
+            <a:r>
+              <a:t>La mitad de los beneficiarios se concentra en 96 de las 1.283 parroquias con cobertura.</a:t>
+            </a:r>
+          </a:p>
+        </p:txBody>
+      </p:sp>
+      <p:sp>
+        <p:nvSpPr>
+          <p:cNvPr id="4" name="Slide Number Placeholder 3"/>
+          <p:cNvSpPr>
+            <a:spLocks noGrp="1"/>
+          </p:cNvSpPr>
+          <p:nvPr>
+            <p:ph type="sldNum" idx="5" sz="quarter"/>
+          </p:nvPr>
+        </p:nvSpPr>
+        <p:spPr/>
+      </p:sp>
+    </p:spTree>
+  </p:cSld>
+  <p:clrMapOvr>
+    <a:masterClrMapping/>
+  </p:clrMapOvr>
+</p:notes>
+</file>
+
+<file path=ppt/notesSlides/notesSlide5.xml><?xml version="1.0" encoding="utf-8"?>
+<p:notes xmlns:a="http://schemas.openxmlformats.org/drawingml/2006/main" xmlns:p="http://schemas.openxmlformats.org/presentationml/2006/main" xmlns:r="http://schemas.openxmlformats.org/officeDocument/2006/relationships">
+  <p:cSld>
+    <p:spTree>
+      <p:nvGrpSpPr>
+        <p:cNvPr id="1" name=""/>
+        <p:cNvGrpSpPr/>
+        <p:nvPr/>
+      </p:nvGrpSpPr>
+      <p:grpSpPr>
+        <a:xfrm>
+          <a:off x="0" y="0"/>
+          <a:ext cx="0" cy="0"/>
+          <a:chOff x="0" y="0"/>
+          <a:chExt cx="0" cy="0"/>
+        </a:xfrm>
+      </p:grpSpPr>
+      <p:sp>
+        <p:nvSpPr>
+          <p:cNvPr id="2" name="Slide Image Placeholder 1"/>
+          <p:cNvSpPr>
+            <a:spLocks noGrp="1"/>
+          </p:cNvSpPr>
+          <p:nvPr>
+            <p:ph type="sldImg" idx="2"/>
+          </p:nvPr>
+        </p:nvSpPr>
+        <p:spPr/>
+      </p:sp>
+      <p:sp>
+        <p:nvSpPr>
+          <p:cNvPr id="3" name="Notes Placeholder 2"/>
+          <p:cNvSpPr>
+            <a:spLocks noGrp="1"/>
+          </p:cNvSpPr>
+          <p:nvPr>
+            <p:ph type="body" idx="3" sz="quarter"/>
+          </p:nvPr>
+        </p:nvSpPr>
+        <p:spPr/>
+        <p:txBody>
+          <a:bodyPr/>
+          <a:lstStyle/>
+          <a:p>
+            <a:r>
+              <a:t>El presupuesto ejecutado 2026 asciende a USD 1.011,2 millones, el 71,0 % del presupuesto codificado.</a:t>
+            </a:r>
+          </a:p>
+        </p:txBody>
+      </p:sp>
+      <p:sp>
+        <p:nvSpPr>
+          <p:cNvPr id="4" name="Slide Number Placeholder 3"/>
+          <p:cNvSpPr>
+            <a:spLocks noGrp="1"/>
+          </p:cNvSpPr>
+          <p:nvPr>
+            <p:ph type="sldNum" idx="5" sz="quarter"/>
+          </p:nvPr>
+        </p:nvSpPr>
+        <p:spPr/>
+      </p:sp>
+    </p:spTree>
+  </p:cSld>
+  <p:clrMapOvr>
+    <a:masterClrMapping/>
+  </p:clrMapOvr>
+</p:notes>
+</file>
+
+<file path=ppt/notesSlides/notesSlide6.xml><?xml version="1.0" encoding="utf-8"?>
+<p:notes xmlns:a="http://schemas.openxmlformats.org/drawingml/2006/main" xmlns:p="http://schemas.openxmlformats.org/presentationml/2006/main" xmlns:r="http://schemas.openxmlformats.org/officeDocument/2006/relationships">
+  <p:cSld>
+    <p:spTree>
+      <p:nvGrpSpPr>
+        <p:cNvPr id="1" name=""/>
+        <p:cNvGrpSpPr/>
+        <p:nvPr/>
+      </p:nvGrpSpPr>
+      <p:grpSpPr>
+        <a:xfrm>
+          <a:off x="0" y="0"/>
+          <a:ext cx="0" cy="0"/>
+          <a:chOff x="0" y="0"/>
+          <a:chExt cx="0" cy="0"/>
+        </a:xfrm>
+      </p:grpSpPr>
+      <p:sp>
+        <p:nvSpPr>
+          <p:cNvPr id="2" name="Slide Image Placeholder 1"/>
+          <p:cNvSpPr>
+            <a:spLocks noGrp="1"/>
+          </p:cNvSpPr>
+          <p:nvPr>
+            <p:ph type="sldImg" idx="2"/>
+          </p:nvPr>
+        </p:nvSpPr>
+        <p:spPr/>
+      </p:sp>
+      <p:sp>
+        <p:nvSpPr>
+          <p:cNvPr id="3" name="Notes Placeholder 2"/>
+          <p:cNvSpPr>
+            <a:spLocks noGrp="1"/>
+          </p:cNvSpPr>
+          <p:nvPr>
+            <p:ph type="body" idx="3" sz="quarter"/>
+          </p:nvPr>
+        </p:nvSpPr>
+        <p:spPr/>
+        <p:txBody>
+          <a:bodyPr/>
+          <a:lstStyle/>
+          <a:p>
+            <a:r>
+              <a:t>Bono de Desarrollo Humano concentra el 39,2 % de los beneficiarios, con 619.073 personas. Bono de Desarrollo Humano registra el 26,7 % del presupuesto ejecutado 2026, con USD 270,2 millones. Guayaquil es el cantón con más beneficiarios: 133.941, el 8,5 % del país.</a:t>
             </a:r>
           </a:p>
         </p:txBody>
@@ -3894,7 +4274,7 @@
         </p:blipFill>
         <p:spPr>
           <a:xfrm>
-            <a:off x="685800" y="3520440"/>
+            <a:off x="685800" y="3611880"/>
             <a:ext cx="3794760" cy="3343003"/>
           </a:xfrm>
           <a:prstGeom prst="rect">
@@ -4423,7 +4803,7 @@
       </p:sp>
       <p:pic>
         <p:nvPicPr>
-          <p:cNvPr id="20" name="Picture 19" descr="layers-blanco.png"/>
+          <p:cNvPr id="20" name="Picture 19" descr="target-blanco.png"/>
           <p:cNvPicPr>
             <a:picLocks noChangeAspect="1"/>
           </p:cNvPicPr>
@@ -4479,7 +4859,7 @@
                 </a:solidFill>
                 <a:latin typeface="Calibri"/>
               </a:rPr>
-              <a:t>Programas con beneficiarios</a:t>
+              <a:t>Ejecución presupuestaria</a:t>
             </a:r>
           </a:p>
         </p:txBody>
@@ -4514,7 +4894,7 @@
                 </a:solidFill>
                 <a:latin typeface="Century Gothic"/>
               </a:rPr>
-              <a:t>6</a:t>
+              <a:t>71,0 %</a:t>
             </a:r>
           </a:p>
         </p:txBody>
@@ -4549,7 +4929,7 @@
                 </a:solidFill>
                 <a:latin typeface="Calibri"/>
               </a:rPr>
-              <a:t>De 8 programas</a:t>
+              <a:t>Codificado: USD 1.423,9 M</a:t>
             </a:r>
           </a:p>
         </p:txBody>
@@ -4706,7 +5086,7 @@
                 </a:solidFill>
                 <a:latin typeface="Calibri"/>
               </a:rPr>
-              <a:t>Presupuesto 2026</a:t>
+              <a:t>Presupuesto ejecutado 2026</a:t>
             </a:r>
           </a:p>
         </p:txBody>
@@ -4968,7 +5348,7 @@
                 </a:solidFill>
                 <a:latin typeface="Calibri"/>
               </a:rPr>
-              <a:t>Fuente: Ministerio de Trabajo y Desarrollo Humano · 22 de octubre de 2026</a:t>
+              <a:t>Fuente: Ministerio de Trabajo y Desarrollo Humano · 23 de octubre de 2026</a:t>
             </a:r>
           </a:p>
         </p:txBody>
@@ -5003,7 +5383,7 @@
                 </a:solidFill>
                 <a:latin typeface="Calibri"/>
               </a:rPr>
-              <a:t>1 / 3</a:t>
+              <a:t>1 / 6</a:t>
             </a:r>
           </a:p>
         </p:txBody>
@@ -5256,7 +5636,7 @@
         <p:spPr>
           <a:xfrm>
             <a:off x="6446520" y="1828800"/>
-            <a:ext cx="3931920" cy="274320"/>
+            <a:ext cx="3749039" cy="274320"/>
           </a:xfrm>
           <a:prstGeom prst="rect">
             <a:avLst/>
@@ -5390,7 +5770,7 @@
         <p:spPr>
           <a:xfrm>
             <a:off x="6446520" y="2304288"/>
-            <a:ext cx="3931920" cy="274320"/>
+            <a:ext cx="3749039" cy="274320"/>
           </a:xfrm>
           <a:prstGeom prst="rect">
             <a:avLst/>
@@ -5524,7 +5904,7 @@
         <p:spPr>
           <a:xfrm>
             <a:off x="6446520" y="2779776"/>
-            <a:ext cx="3931920" cy="274320"/>
+            <a:ext cx="3749039" cy="274320"/>
           </a:xfrm>
           <a:prstGeom prst="rect">
             <a:avLst/>
@@ -5658,7 +6038,7 @@
         <p:spPr>
           <a:xfrm>
             <a:off x="6446520" y="3255264"/>
-            <a:ext cx="3931920" cy="274320"/>
+            <a:ext cx="3749039" cy="274320"/>
           </a:xfrm>
           <a:prstGeom prst="rect">
             <a:avLst/>
@@ -5792,7 +6172,7 @@
         <p:spPr>
           <a:xfrm>
             <a:off x="6446520" y="3730752"/>
-            <a:ext cx="3931920" cy="274320"/>
+            <a:ext cx="3749039" cy="274320"/>
           </a:xfrm>
           <a:prstGeom prst="rect">
             <a:avLst/>
@@ -5926,7 +6306,7 @@
         <p:spPr>
           <a:xfrm>
             <a:off x="6446520" y="4206240"/>
-            <a:ext cx="3931920" cy="274320"/>
+            <a:ext cx="3749039" cy="274320"/>
           </a:xfrm>
           <a:prstGeom prst="rect">
             <a:avLst/>
@@ -6060,7 +6440,7 @@
         <p:spPr>
           <a:xfrm>
             <a:off x="6446520" y="4681727"/>
-            <a:ext cx="3931920" cy="274320"/>
+            <a:ext cx="3749039" cy="274320"/>
           </a:xfrm>
           <a:prstGeom prst="rect">
             <a:avLst/>
@@ -6279,8 +6659,8 @@
         </p:nvSpPr>
         <p:spPr>
           <a:xfrm>
-            <a:off x="7315200" y="5440680"/>
-            <a:ext cx="4160520" cy="731520"/>
+            <a:off x="7315200" y="5431536"/>
+            <a:ext cx="4160520" cy="713232"/>
           </a:xfrm>
           <a:prstGeom prst="rect">
             <a:avLst/>
@@ -6336,7 +6716,7 @@
                 </a:solidFill>
                 <a:latin typeface="Calibri"/>
               </a:rPr>
-              <a:t>Fuente: Ministerio de Trabajo y Desarrollo Humano · 22 de octubre de 2026</a:t>
+              <a:t>Fuente: Ministerio de Trabajo y Desarrollo Humano · 23 de octubre de 2026</a:t>
             </a:r>
           </a:p>
         </p:txBody>
@@ -6371,7 +6751,7 @@
                 </a:solidFill>
                 <a:latin typeface="Calibri"/>
               </a:rPr>
-              <a:t>2 / 3</a:t>
+              <a:t>2 / 6</a:t>
             </a:r>
           </a:p>
         </p:txBody>
@@ -6492,6 +6872,4139 @@
                 </a:solidFill>
                 <a:latin typeface="Century Gothic"/>
               </a:rPr>
+              <a:t>Resultados por cantón</a:t>
+            </a:r>
+          </a:p>
+        </p:txBody>
+      </p:sp>
+      <p:sp>
+        <p:nvSpPr>
+          <p:cNvPr id="5" name="TextBox 4"/>
+          <p:cNvSpPr txBox="1"/>
+          <p:nvPr/>
+        </p:nvSpPr>
+        <p:spPr>
+          <a:xfrm>
+            <a:off x="502920" y="640080"/>
+            <a:ext cx="8595360" cy="292608"/>
+          </a:xfrm>
+          <a:prstGeom prst="rect">
+            <a:avLst/>
+          </a:prstGeom>
+          <a:noFill/>
+        </p:spPr>
+        <p:txBody>
+          <a:bodyPr wrap="square" anchor="t" lIns="0" rIns="0" tIns="0" bIns="0">
+            <a:spAutoFit/>
+          </a:bodyPr>
+          <a:lstStyle/>
+          <a:p>
+            <a:pPr algn="l"/>
+            <a:r>
+              <a:rPr sz="1250" b="0">
+                <a:solidFill>
+                  <a:srgbClr val="E4DBF3"/>
+                </a:solidFill>
+                <a:latin typeface="Calibri"/>
+              </a:rPr>
+              <a:t>Beneficiarios · Septiembre 2026 · Nacional</a:t>
+            </a:r>
+          </a:p>
+        </p:txBody>
+      </p:sp>
+      <p:pic>
+        <p:nvPicPr>
+          <p:cNvPr id="6" name="Picture 5" descr="mtdh_logo.png"/>
+          <p:cNvPicPr>
+            <a:picLocks noChangeAspect="1"/>
+          </p:cNvPicPr>
+          <p:nvPr/>
+        </p:nvPicPr>
+        <p:blipFill>
+          <a:blip r:embed="rId2"/>
+          <a:stretch>
+            <a:fillRect/>
+          </a:stretch>
+        </p:blipFill>
+        <p:spPr>
+          <a:xfrm>
+            <a:off x="9372600" y="256032"/>
+            <a:ext cx="2380293" cy="566928"/>
+          </a:xfrm>
+          <a:prstGeom prst="rect">
+            <a:avLst/>
+          </a:prstGeom>
+        </p:spPr>
+      </p:pic>
+      <p:pic>
+        <p:nvPicPr>
+          <p:cNvPr id="7" name="Picture 6" descr="image.png"/>
+          <p:cNvPicPr>
+            <a:picLocks noChangeAspect="1"/>
+          </p:cNvPicPr>
+          <p:nvPr/>
+        </p:nvPicPr>
+        <p:blipFill>
+          <a:blip r:embed="rId3"/>
+          <a:stretch>
+            <a:fillRect/>
+          </a:stretch>
+        </p:blipFill>
+        <p:spPr>
+          <a:xfrm>
+            <a:off x="411480" y="1298448"/>
+            <a:ext cx="5638800" cy="5074920"/>
+          </a:xfrm>
+          <a:prstGeom prst="rect">
+            <a:avLst/>
+          </a:prstGeom>
+        </p:spPr>
+      </p:pic>
+      <p:sp>
+        <p:nvSpPr>
+          <p:cNvPr id="8" name="TextBox 7"/>
+          <p:cNvSpPr txBox="1"/>
+          <p:nvPr/>
+        </p:nvSpPr>
+        <p:spPr>
+          <a:xfrm>
+            <a:off x="6446520" y="1325880"/>
+            <a:ext cx="5212080" cy="365760"/>
+          </a:xfrm>
+          <a:prstGeom prst="rect">
+            <a:avLst/>
+          </a:prstGeom>
+          <a:noFill/>
+        </p:spPr>
+        <p:txBody>
+          <a:bodyPr wrap="square" anchor="t" lIns="0" rIns="0" tIns="0" bIns="0">
+            <a:spAutoFit/>
+          </a:bodyPr>
+          <a:lstStyle/>
+          <a:p>
+            <a:pPr algn="l"/>
+            <a:r>
+              <a:rPr sz="1800" b="1">
+                <a:solidFill>
+                  <a:srgbClr val="2B164F"/>
+                </a:solidFill>
+                <a:latin typeface="Century Gothic"/>
+              </a:rPr>
+              <a:t>Principales cantones</a:t>
+            </a:r>
+          </a:p>
+        </p:txBody>
+      </p:sp>
+      <p:sp>
+        <p:nvSpPr>
+          <p:cNvPr id="9" name="TextBox 8"/>
+          <p:cNvSpPr txBox="1"/>
+          <p:nvPr/>
+        </p:nvSpPr>
+        <p:spPr>
+          <a:xfrm>
+            <a:off x="6446520" y="1828800"/>
+            <a:ext cx="3749039" cy="274320"/>
+          </a:xfrm>
+          <a:prstGeom prst="rect">
+            <a:avLst/>
+          </a:prstGeom>
+          <a:noFill/>
+        </p:spPr>
+        <p:txBody>
+          <a:bodyPr wrap="square" anchor="t" lIns="0" rIns="0" tIns="0" bIns="0">
+            <a:spAutoFit/>
+          </a:bodyPr>
+          <a:lstStyle/>
+          <a:p>
+            <a:pPr algn="l"/>
+            <a:r>
+              <a:rPr sz="1350" b="0">
+                <a:solidFill>
+                  <a:srgbClr val="20202B"/>
+                </a:solidFill>
+                <a:latin typeface="Calibri"/>
+              </a:rPr>
+              <a:t>1. Guayaquil</a:t>
+            </a:r>
+          </a:p>
+        </p:txBody>
+      </p:sp>
+      <p:sp>
+        <p:nvSpPr>
+          <p:cNvPr id="10" name="TextBox 9"/>
+          <p:cNvSpPr txBox="1"/>
+          <p:nvPr/>
+        </p:nvSpPr>
+        <p:spPr>
+          <a:xfrm>
+            <a:off x="9829800" y="1828800"/>
+            <a:ext cx="1828800" cy="274320"/>
+          </a:xfrm>
+          <a:prstGeom prst="rect">
+            <a:avLst/>
+          </a:prstGeom>
+          <a:noFill/>
+        </p:spPr>
+        <p:txBody>
+          <a:bodyPr wrap="square" anchor="t" lIns="0" rIns="0" tIns="0" bIns="0">
+            <a:spAutoFit/>
+          </a:bodyPr>
+          <a:lstStyle/>
+          <a:p>
+            <a:pPr algn="r"/>
+            <a:r>
+              <a:rPr sz="1350" b="1">
+                <a:solidFill>
+                  <a:srgbClr val="20202B"/>
+                </a:solidFill>
+                <a:latin typeface="Calibri"/>
+              </a:rPr>
+              <a:t>133.941</a:t>
+            </a:r>
+          </a:p>
+        </p:txBody>
+      </p:sp>
+      <p:sp>
+        <p:nvSpPr>
+          <p:cNvPr id="11" name="Rounded Rectangle 10"/>
+          <p:cNvSpPr/>
+          <p:nvPr/>
+        </p:nvSpPr>
+        <p:spPr>
+          <a:xfrm>
+            <a:off x="6446520" y="2130552"/>
+            <a:ext cx="5212080" cy="82296"/>
+          </a:xfrm>
+          <a:prstGeom prst="roundRect">
+            <a:avLst>
+              <a:gd name="adj" fmla="val 50000"/>
+            </a:avLst>
+          </a:prstGeom>
+          <a:solidFill>
+            <a:srgbClr val="EFECF5"/>
+          </a:solidFill>
+          <a:ln>
+            <a:noFill/>
+          </a:ln>
+          <a:effectLst/>
+        </p:spPr>
+        <p:txBody>
+          <a:bodyPr rtlCol="0" anchor="ctr"/>
+          <a:lstStyle/>
+          <a:p>
+            <a:pPr algn="ctr"/>
+          </a:p>
+        </p:txBody>
+      </p:sp>
+      <p:sp>
+        <p:nvSpPr>
+          <p:cNvPr id="12" name="Rounded Rectangle 11"/>
+          <p:cNvSpPr/>
+          <p:nvPr/>
+        </p:nvSpPr>
+        <p:spPr>
+          <a:xfrm>
+            <a:off x="6446520" y="2130552"/>
+            <a:ext cx="5212080" cy="82296"/>
+          </a:xfrm>
+          <a:prstGeom prst="roundRect">
+            <a:avLst>
+              <a:gd name="adj" fmla="val 50000"/>
+            </a:avLst>
+          </a:prstGeom>
+          <a:solidFill>
+            <a:srgbClr val="5A369A"/>
+          </a:solidFill>
+          <a:ln>
+            <a:noFill/>
+          </a:ln>
+          <a:effectLst/>
+        </p:spPr>
+        <p:txBody>
+          <a:bodyPr rtlCol="0" anchor="ctr"/>
+          <a:lstStyle/>
+          <a:p>
+            <a:pPr algn="ctr"/>
+          </a:p>
+        </p:txBody>
+      </p:sp>
+      <p:sp>
+        <p:nvSpPr>
+          <p:cNvPr id="13" name="TextBox 12"/>
+          <p:cNvSpPr txBox="1"/>
+          <p:nvPr/>
+        </p:nvSpPr>
+        <p:spPr>
+          <a:xfrm>
+            <a:off x="6446520" y="2304288"/>
+            <a:ext cx="3749039" cy="274320"/>
+          </a:xfrm>
+          <a:prstGeom prst="rect">
+            <a:avLst/>
+          </a:prstGeom>
+          <a:noFill/>
+        </p:spPr>
+        <p:txBody>
+          <a:bodyPr wrap="square" anchor="t" lIns="0" rIns="0" tIns="0" bIns="0">
+            <a:spAutoFit/>
+          </a:bodyPr>
+          <a:lstStyle/>
+          <a:p>
+            <a:pPr algn="l"/>
+            <a:r>
+              <a:rPr sz="1350" b="0">
+                <a:solidFill>
+                  <a:srgbClr val="20202B"/>
+                </a:solidFill>
+                <a:latin typeface="Calibri"/>
+              </a:rPr>
+              <a:t>2. Quito</a:t>
+            </a:r>
+          </a:p>
+        </p:txBody>
+      </p:sp>
+      <p:sp>
+        <p:nvSpPr>
+          <p:cNvPr id="14" name="TextBox 13"/>
+          <p:cNvSpPr txBox="1"/>
+          <p:nvPr/>
+        </p:nvSpPr>
+        <p:spPr>
+          <a:xfrm>
+            <a:off x="9829800" y="2304288"/>
+            <a:ext cx="1828800" cy="274320"/>
+          </a:xfrm>
+          <a:prstGeom prst="rect">
+            <a:avLst/>
+          </a:prstGeom>
+          <a:noFill/>
+        </p:spPr>
+        <p:txBody>
+          <a:bodyPr wrap="square" anchor="t" lIns="0" rIns="0" tIns="0" bIns="0">
+            <a:spAutoFit/>
+          </a:bodyPr>
+          <a:lstStyle/>
+          <a:p>
+            <a:pPr algn="r"/>
+            <a:r>
+              <a:rPr sz="1350" b="1">
+                <a:solidFill>
+                  <a:srgbClr val="20202B"/>
+                </a:solidFill>
+                <a:latin typeface="Calibri"/>
+              </a:rPr>
+              <a:t>77.405</a:t>
+            </a:r>
+          </a:p>
+        </p:txBody>
+      </p:sp>
+      <p:sp>
+        <p:nvSpPr>
+          <p:cNvPr id="15" name="Rounded Rectangle 14"/>
+          <p:cNvSpPr/>
+          <p:nvPr/>
+        </p:nvSpPr>
+        <p:spPr>
+          <a:xfrm>
+            <a:off x="6446520" y="2606040"/>
+            <a:ext cx="5212080" cy="82296"/>
+          </a:xfrm>
+          <a:prstGeom prst="roundRect">
+            <a:avLst>
+              <a:gd name="adj" fmla="val 50000"/>
+            </a:avLst>
+          </a:prstGeom>
+          <a:solidFill>
+            <a:srgbClr val="EFECF5"/>
+          </a:solidFill>
+          <a:ln>
+            <a:noFill/>
+          </a:ln>
+          <a:effectLst/>
+        </p:spPr>
+        <p:txBody>
+          <a:bodyPr rtlCol="0" anchor="ctr"/>
+          <a:lstStyle/>
+          <a:p>
+            <a:pPr algn="ctr"/>
+          </a:p>
+        </p:txBody>
+      </p:sp>
+      <p:sp>
+        <p:nvSpPr>
+          <p:cNvPr id="16" name="Rounded Rectangle 15"/>
+          <p:cNvSpPr/>
+          <p:nvPr/>
+        </p:nvSpPr>
+        <p:spPr>
+          <a:xfrm>
+            <a:off x="6446520" y="2606040"/>
+            <a:ext cx="3012080" cy="82296"/>
+          </a:xfrm>
+          <a:prstGeom prst="roundRect">
+            <a:avLst>
+              <a:gd name="adj" fmla="val 50000"/>
+            </a:avLst>
+          </a:prstGeom>
+          <a:solidFill>
+            <a:srgbClr val="5A369A"/>
+          </a:solidFill>
+          <a:ln>
+            <a:noFill/>
+          </a:ln>
+          <a:effectLst/>
+        </p:spPr>
+        <p:txBody>
+          <a:bodyPr rtlCol="0" anchor="ctr"/>
+          <a:lstStyle/>
+          <a:p>
+            <a:pPr algn="ctr"/>
+          </a:p>
+        </p:txBody>
+      </p:sp>
+      <p:sp>
+        <p:nvSpPr>
+          <p:cNvPr id="17" name="TextBox 16"/>
+          <p:cNvSpPr txBox="1"/>
+          <p:nvPr/>
+        </p:nvSpPr>
+        <p:spPr>
+          <a:xfrm>
+            <a:off x="6446520" y="2779776"/>
+            <a:ext cx="3749039" cy="274320"/>
+          </a:xfrm>
+          <a:prstGeom prst="rect">
+            <a:avLst/>
+          </a:prstGeom>
+          <a:noFill/>
+        </p:spPr>
+        <p:txBody>
+          <a:bodyPr wrap="square" anchor="t" lIns="0" rIns="0" tIns="0" bIns="0">
+            <a:spAutoFit/>
+          </a:bodyPr>
+          <a:lstStyle/>
+          <a:p>
+            <a:pPr algn="l"/>
+            <a:r>
+              <a:rPr sz="1350" b="0">
+                <a:solidFill>
+                  <a:srgbClr val="20202B"/>
+                </a:solidFill>
+                <a:latin typeface="Calibri"/>
+              </a:rPr>
+              <a:t>3. Santo Domingo</a:t>
+            </a:r>
+          </a:p>
+        </p:txBody>
+      </p:sp>
+      <p:sp>
+        <p:nvSpPr>
+          <p:cNvPr id="18" name="TextBox 17"/>
+          <p:cNvSpPr txBox="1"/>
+          <p:nvPr/>
+        </p:nvSpPr>
+        <p:spPr>
+          <a:xfrm>
+            <a:off x="9829800" y="2779776"/>
+            <a:ext cx="1828800" cy="274320"/>
+          </a:xfrm>
+          <a:prstGeom prst="rect">
+            <a:avLst/>
+          </a:prstGeom>
+          <a:noFill/>
+        </p:spPr>
+        <p:txBody>
+          <a:bodyPr wrap="square" anchor="t" lIns="0" rIns="0" tIns="0" bIns="0">
+            <a:spAutoFit/>
+          </a:bodyPr>
+          <a:lstStyle/>
+          <a:p>
+            <a:pPr algn="r"/>
+            <a:r>
+              <a:rPr sz="1350" b="1">
+                <a:solidFill>
+                  <a:srgbClr val="20202B"/>
+                </a:solidFill>
+                <a:latin typeface="Calibri"/>
+              </a:rPr>
+              <a:t>39.156</a:t>
+            </a:r>
+          </a:p>
+        </p:txBody>
+      </p:sp>
+      <p:sp>
+        <p:nvSpPr>
+          <p:cNvPr id="19" name="Rounded Rectangle 18"/>
+          <p:cNvSpPr/>
+          <p:nvPr/>
+        </p:nvSpPr>
+        <p:spPr>
+          <a:xfrm>
+            <a:off x="6446520" y="3081528"/>
+            <a:ext cx="5212080" cy="82296"/>
+          </a:xfrm>
+          <a:prstGeom prst="roundRect">
+            <a:avLst>
+              <a:gd name="adj" fmla="val 50000"/>
+            </a:avLst>
+          </a:prstGeom>
+          <a:solidFill>
+            <a:srgbClr val="EFECF5"/>
+          </a:solidFill>
+          <a:ln>
+            <a:noFill/>
+          </a:ln>
+          <a:effectLst/>
+        </p:spPr>
+        <p:txBody>
+          <a:bodyPr rtlCol="0" anchor="ctr"/>
+          <a:lstStyle/>
+          <a:p>
+            <a:pPr algn="ctr"/>
+          </a:p>
+        </p:txBody>
+      </p:sp>
+      <p:sp>
+        <p:nvSpPr>
+          <p:cNvPr id="20" name="Rounded Rectangle 19"/>
+          <p:cNvSpPr/>
+          <p:nvPr/>
+        </p:nvSpPr>
+        <p:spPr>
+          <a:xfrm>
+            <a:off x="6446520" y="3081528"/>
+            <a:ext cx="1523687" cy="82296"/>
+          </a:xfrm>
+          <a:prstGeom prst="roundRect">
+            <a:avLst>
+              <a:gd name="adj" fmla="val 50000"/>
+            </a:avLst>
+          </a:prstGeom>
+          <a:solidFill>
+            <a:srgbClr val="5A369A"/>
+          </a:solidFill>
+          <a:ln>
+            <a:noFill/>
+          </a:ln>
+          <a:effectLst/>
+        </p:spPr>
+        <p:txBody>
+          <a:bodyPr rtlCol="0" anchor="ctr"/>
+          <a:lstStyle/>
+          <a:p>
+            <a:pPr algn="ctr"/>
+          </a:p>
+        </p:txBody>
+      </p:sp>
+      <p:sp>
+        <p:nvSpPr>
+          <p:cNvPr id="21" name="TextBox 20"/>
+          <p:cNvSpPr txBox="1"/>
+          <p:nvPr/>
+        </p:nvSpPr>
+        <p:spPr>
+          <a:xfrm>
+            <a:off x="6446520" y="3255264"/>
+            <a:ext cx="3749039" cy="274320"/>
+          </a:xfrm>
+          <a:prstGeom prst="rect">
+            <a:avLst/>
+          </a:prstGeom>
+          <a:noFill/>
+        </p:spPr>
+        <p:txBody>
+          <a:bodyPr wrap="square" anchor="t" lIns="0" rIns="0" tIns="0" bIns="0">
+            <a:spAutoFit/>
+          </a:bodyPr>
+          <a:lstStyle/>
+          <a:p>
+            <a:pPr algn="l"/>
+            <a:r>
+              <a:rPr sz="1350" b="0">
+                <a:solidFill>
+                  <a:srgbClr val="20202B"/>
+                </a:solidFill>
+                <a:latin typeface="Calibri"/>
+              </a:rPr>
+              <a:t>4. Esmeraldas</a:t>
+            </a:r>
+          </a:p>
+        </p:txBody>
+      </p:sp>
+      <p:sp>
+        <p:nvSpPr>
+          <p:cNvPr id="22" name="TextBox 21"/>
+          <p:cNvSpPr txBox="1"/>
+          <p:nvPr/>
+        </p:nvSpPr>
+        <p:spPr>
+          <a:xfrm>
+            <a:off x="9829800" y="3255264"/>
+            <a:ext cx="1828800" cy="274320"/>
+          </a:xfrm>
+          <a:prstGeom prst="rect">
+            <a:avLst/>
+          </a:prstGeom>
+          <a:noFill/>
+        </p:spPr>
+        <p:txBody>
+          <a:bodyPr wrap="square" anchor="t" lIns="0" rIns="0" tIns="0" bIns="0">
+            <a:spAutoFit/>
+          </a:bodyPr>
+          <a:lstStyle/>
+          <a:p>
+            <a:pPr algn="r"/>
+            <a:r>
+              <a:rPr sz="1350" b="1">
+                <a:solidFill>
+                  <a:srgbClr val="20202B"/>
+                </a:solidFill>
+                <a:latin typeface="Calibri"/>
+              </a:rPr>
+              <a:t>30.145</a:t>
+            </a:r>
+          </a:p>
+        </p:txBody>
+      </p:sp>
+      <p:sp>
+        <p:nvSpPr>
+          <p:cNvPr id="23" name="Rounded Rectangle 22"/>
+          <p:cNvSpPr/>
+          <p:nvPr/>
+        </p:nvSpPr>
+        <p:spPr>
+          <a:xfrm>
+            <a:off x="6446520" y="3557016"/>
+            <a:ext cx="5212080" cy="82296"/>
+          </a:xfrm>
+          <a:prstGeom prst="roundRect">
+            <a:avLst>
+              <a:gd name="adj" fmla="val 50000"/>
+            </a:avLst>
+          </a:prstGeom>
+          <a:solidFill>
+            <a:srgbClr val="EFECF5"/>
+          </a:solidFill>
+          <a:ln>
+            <a:noFill/>
+          </a:ln>
+          <a:effectLst/>
+        </p:spPr>
+        <p:txBody>
+          <a:bodyPr rtlCol="0" anchor="ctr"/>
+          <a:lstStyle/>
+          <a:p>
+            <a:pPr algn="ctr"/>
+          </a:p>
+        </p:txBody>
+      </p:sp>
+      <p:sp>
+        <p:nvSpPr>
+          <p:cNvPr id="24" name="Rounded Rectangle 23"/>
+          <p:cNvSpPr/>
+          <p:nvPr/>
+        </p:nvSpPr>
+        <p:spPr>
+          <a:xfrm>
+            <a:off x="6446520" y="3557016"/>
+            <a:ext cx="1173040" cy="82296"/>
+          </a:xfrm>
+          <a:prstGeom prst="roundRect">
+            <a:avLst>
+              <a:gd name="adj" fmla="val 50000"/>
+            </a:avLst>
+          </a:prstGeom>
+          <a:solidFill>
+            <a:srgbClr val="5A369A"/>
+          </a:solidFill>
+          <a:ln>
+            <a:noFill/>
+          </a:ln>
+          <a:effectLst/>
+        </p:spPr>
+        <p:txBody>
+          <a:bodyPr rtlCol="0" anchor="ctr"/>
+          <a:lstStyle/>
+          <a:p>
+            <a:pPr algn="ctr"/>
+          </a:p>
+        </p:txBody>
+      </p:sp>
+      <p:sp>
+        <p:nvSpPr>
+          <p:cNvPr id="25" name="TextBox 24"/>
+          <p:cNvSpPr txBox="1"/>
+          <p:nvPr/>
+        </p:nvSpPr>
+        <p:spPr>
+          <a:xfrm>
+            <a:off x="6446520" y="3730752"/>
+            <a:ext cx="3749039" cy="274320"/>
+          </a:xfrm>
+          <a:prstGeom prst="rect">
+            <a:avLst/>
+          </a:prstGeom>
+          <a:noFill/>
+        </p:spPr>
+        <p:txBody>
+          <a:bodyPr wrap="square" anchor="t" lIns="0" rIns="0" tIns="0" bIns="0">
+            <a:spAutoFit/>
+          </a:bodyPr>
+          <a:lstStyle/>
+          <a:p>
+            <a:pPr algn="l"/>
+            <a:r>
+              <a:rPr sz="1350" b="0">
+                <a:solidFill>
+                  <a:srgbClr val="20202B"/>
+                </a:solidFill>
+                <a:latin typeface="Calibri"/>
+              </a:rPr>
+              <a:t>5. Portoviejo</a:t>
+            </a:r>
+          </a:p>
+        </p:txBody>
+      </p:sp>
+      <p:sp>
+        <p:nvSpPr>
+          <p:cNvPr id="26" name="TextBox 25"/>
+          <p:cNvSpPr txBox="1"/>
+          <p:nvPr/>
+        </p:nvSpPr>
+        <p:spPr>
+          <a:xfrm>
+            <a:off x="9829800" y="3730752"/>
+            <a:ext cx="1828800" cy="274320"/>
+          </a:xfrm>
+          <a:prstGeom prst="rect">
+            <a:avLst/>
+          </a:prstGeom>
+          <a:noFill/>
+        </p:spPr>
+        <p:txBody>
+          <a:bodyPr wrap="square" anchor="t" lIns="0" rIns="0" tIns="0" bIns="0">
+            <a:spAutoFit/>
+          </a:bodyPr>
+          <a:lstStyle/>
+          <a:p>
+            <a:pPr algn="r"/>
+            <a:r>
+              <a:rPr sz="1350" b="1">
+                <a:solidFill>
+                  <a:srgbClr val="20202B"/>
+                </a:solidFill>
+                <a:latin typeface="Calibri"/>
+              </a:rPr>
+              <a:t>28.612</a:t>
+            </a:r>
+          </a:p>
+        </p:txBody>
+      </p:sp>
+      <p:sp>
+        <p:nvSpPr>
+          <p:cNvPr id="27" name="Rounded Rectangle 26"/>
+          <p:cNvSpPr/>
+          <p:nvPr/>
+        </p:nvSpPr>
+        <p:spPr>
+          <a:xfrm>
+            <a:off x="6446520" y="4032504"/>
+            <a:ext cx="5212080" cy="82296"/>
+          </a:xfrm>
+          <a:prstGeom prst="roundRect">
+            <a:avLst>
+              <a:gd name="adj" fmla="val 50000"/>
+            </a:avLst>
+          </a:prstGeom>
+          <a:solidFill>
+            <a:srgbClr val="EFECF5"/>
+          </a:solidFill>
+          <a:ln>
+            <a:noFill/>
+          </a:ln>
+          <a:effectLst/>
+        </p:spPr>
+        <p:txBody>
+          <a:bodyPr rtlCol="0" anchor="ctr"/>
+          <a:lstStyle/>
+          <a:p>
+            <a:pPr algn="ctr"/>
+          </a:p>
+        </p:txBody>
+      </p:sp>
+      <p:sp>
+        <p:nvSpPr>
+          <p:cNvPr id="28" name="Rounded Rectangle 27"/>
+          <p:cNvSpPr/>
+          <p:nvPr/>
+        </p:nvSpPr>
+        <p:spPr>
+          <a:xfrm>
+            <a:off x="6446520" y="4032504"/>
+            <a:ext cx="1113385" cy="82296"/>
+          </a:xfrm>
+          <a:prstGeom prst="roundRect">
+            <a:avLst>
+              <a:gd name="adj" fmla="val 50000"/>
+            </a:avLst>
+          </a:prstGeom>
+          <a:solidFill>
+            <a:srgbClr val="5A369A"/>
+          </a:solidFill>
+          <a:ln>
+            <a:noFill/>
+          </a:ln>
+          <a:effectLst/>
+        </p:spPr>
+        <p:txBody>
+          <a:bodyPr rtlCol="0" anchor="ctr"/>
+          <a:lstStyle/>
+          <a:p>
+            <a:pPr algn="ctr"/>
+          </a:p>
+        </p:txBody>
+      </p:sp>
+      <p:sp>
+        <p:nvSpPr>
+          <p:cNvPr id="29" name="TextBox 28"/>
+          <p:cNvSpPr txBox="1"/>
+          <p:nvPr/>
+        </p:nvSpPr>
+        <p:spPr>
+          <a:xfrm>
+            <a:off x="6446520" y="4206240"/>
+            <a:ext cx="3749039" cy="274320"/>
+          </a:xfrm>
+          <a:prstGeom prst="rect">
+            <a:avLst/>
+          </a:prstGeom>
+          <a:noFill/>
+        </p:spPr>
+        <p:txBody>
+          <a:bodyPr wrap="square" anchor="t" lIns="0" rIns="0" tIns="0" bIns="0">
+            <a:spAutoFit/>
+          </a:bodyPr>
+          <a:lstStyle/>
+          <a:p>
+            <a:pPr algn="l"/>
+            <a:r>
+              <a:rPr sz="1350" b="0">
+                <a:solidFill>
+                  <a:srgbClr val="20202B"/>
+                </a:solidFill>
+                <a:latin typeface="Calibri"/>
+              </a:rPr>
+              <a:t>6. Ambato</a:t>
+            </a:r>
+          </a:p>
+        </p:txBody>
+      </p:sp>
+      <p:sp>
+        <p:nvSpPr>
+          <p:cNvPr id="30" name="TextBox 29"/>
+          <p:cNvSpPr txBox="1"/>
+          <p:nvPr/>
+        </p:nvSpPr>
+        <p:spPr>
+          <a:xfrm>
+            <a:off x="9829800" y="4206240"/>
+            <a:ext cx="1828800" cy="274320"/>
+          </a:xfrm>
+          <a:prstGeom prst="rect">
+            <a:avLst/>
+          </a:prstGeom>
+          <a:noFill/>
+        </p:spPr>
+        <p:txBody>
+          <a:bodyPr wrap="square" anchor="t" lIns="0" rIns="0" tIns="0" bIns="0">
+            <a:spAutoFit/>
+          </a:bodyPr>
+          <a:lstStyle/>
+          <a:p>
+            <a:pPr algn="r"/>
+            <a:r>
+              <a:rPr sz="1350" b="1">
+                <a:solidFill>
+                  <a:srgbClr val="20202B"/>
+                </a:solidFill>
+                <a:latin typeface="Calibri"/>
+              </a:rPr>
+              <a:t>28.074</a:t>
+            </a:r>
+          </a:p>
+        </p:txBody>
+      </p:sp>
+      <p:sp>
+        <p:nvSpPr>
+          <p:cNvPr id="31" name="Rounded Rectangle 30"/>
+          <p:cNvSpPr/>
+          <p:nvPr/>
+        </p:nvSpPr>
+        <p:spPr>
+          <a:xfrm>
+            <a:off x="6446520" y="4507992"/>
+            <a:ext cx="5212080" cy="82296"/>
+          </a:xfrm>
+          <a:prstGeom prst="roundRect">
+            <a:avLst>
+              <a:gd name="adj" fmla="val 50000"/>
+            </a:avLst>
+          </a:prstGeom>
+          <a:solidFill>
+            <a:srgbClr val="EFECF5"/>
+          </a:solidFill>
+          <a:ln>
+            <a:noFill/>
+          </a:ln>
+          <a:effectLst/>
+        </p:spPr>
+        <p:txBody>
+          <a:bodyPr rtlCol="0" anchor="ctr"/>
+          <a:lstStyle/>
+          <a:p>
+            <a:pPr algn="ctr"/>
+          </a:p>
+        </p:txBody>
+      </p:sp>
+      <p:sp>
+        <p:nvSpPr>
+          <p:cNvPr id="32" name="Rounded Rectangle 31"/>
+          <p:cNvSpPr/>
+          <p:nvPr/>
+        </p:nvSpPr>
+        <p:spPr>
+          <a:xfrm>
+            <a:off x="6446520" y="4507992"/>
+            <a:ext cx="1092450" cy="82296"/>
+          </a:xfrm>
+          <a:prstGeom prst="roundRect">
+            <a:avLst>
+              <a:gd name="adj" fmla="val 50000"/>
+            </a:avLst>
+          </a:prstGeom>
+          <a:solidFill>
+            <a:srgbClr val="5A369A"/>
+          </a:solidFill>
+          <a:ln>
+            <a:noFill/>
+          </a:ln>
+          <a:effectLst/>
+        </p:spPr>
+        <p:txBody>
+          <a:bodyPr rtlCol="0" anchor="ctr"/>
+          <a:lstStyle/>
+          <a:p>
+            <a:pPr algn="ctr"/>
+          </a:p>
+        </p:txBody>
+      </p:sp>
+      <p:sp>
+        <p:nvSpPr>
+          <p:cNvPr id="33" name="TextBox 32"/>
+          <p:cNvSpPr txBox="1"/>
+          <p:nvPr/>
+        </p:nvSpPr>
+        <p:spPr>
+          <a:xfrm>
+            <a:off x="6446520" y="4681727"/>
+            <a:ext cx="3749039" cy="274320"/>
+          </a:xfrm>
+          <a:prstGeom prst="rect">
+            <a:avLst/>
+          </a:prstGeom>
+          <a:noFill/>
+        </p:spPr>
+        <p:txBody>
+          <a:bodyPr wrap="square" anchor="t" lIns="0" rIns="0" tIns="0" bIns="0">
+            <a:spAutoFit/>
+          </a:bodyPr>
+          <a:lstStyle/>
+          <a:p>
+            <a:pPr algn="l"/>
+            <a:r>
+              <a:rPr sz="1350" b="0">
+                <a:solidFill>
+                  <a:srgbClr val="20202B"/>
+                </a:solidFill>
+                <a:latin typeface="Calibri"/>
+              </a:rPr>
+              <a:t>7. Santa Elena</a:t>
+            </a:r>
+          </a:p>
+        </p:txBody>
+      </p:sp>
+      <p:sp>
+        <p:nvSpPr>
+          <p:cNvPr id="34" name="TextBox 33"/>
+          <p:cNvSpPr txBox="1"/>
+          <p:nvPr/>
+        </p:nvSpPr>
+        <p:spPr>
+          <a:xfrm>
+            <a:off x="9829800" y="4681727"/>
+            <a:ext cx="1828800" cy="274320"/>
+          </a:xfrm>
+          <a:prstGeom prst="rect">
+            <a:avLst/>
+          </a:prstGeom>
+          <a:noFill/>
+        </p:spPr>
+        <p:txBody>
+          <a:bodyPr wrap="square" anchor="t" lIns="0" rIns="0" tIns="0" bIns="0">
+            <a:spAutoFit/>
+          </a:bodyPr>
+          <a:lstStyle/>
+          <a:p>
+            <a:pPr algn="r"/>
+            <a:r>
+              <a:rPr sz="1350" b="1">
+                <a:solidFill>
+                  <a:srgbClr val="20202B"/>
+                </a:solidFill>
+                <a:latin typeface="Calibri"/>
+              </a:rPr>
+              <a:t>26.464</a:t>
+            </a:r>
+          </a:p>
+        </p:txBody>
+      </p:sp>
+      <p:sp>
+        <p:nvSpPr>
+          <p:cNvPr id="35" name="Rounded Rectangle 34"/>
+          <p:cNvSpPr/>
+          <p:nvPr/>
+        </p:nvSpPr>
+        <p:spPr>
+          <a:xfrm>
+            <a:off x="6446520" y="4983479"/>
+            <a:ext cx="5212080" cy="82296"/>
+          </a:xfrm>
+          <a:prstGeom prst="roundRect">
+            <a:avLst>
+              <a:gd name="adj" fmla="val 50000"/>
+            </a:avLst>
+          </a:prstGeom>
+          <a:solidFill>
+            <a:srgbClr val="EFECF5"/>
+          </a:solidFill>
+          <a:ln>
+            <a:noFill/>
+          </a:ln>
+          <a:effectLst/>
+        </p:spPr>
+        <p:txBody>
+          <a:bodyPr rtlCol="0" anchor="ctr"/>
+          <a:lstStyle/>
+          <a:p>
+            <a:pPr algn="ctr"/>
+          </a:p>
+        </p:txBody>
+      </p:sp>
+      <p:sp>
+        <p:nvSpPr>
+          <p:cNvPr id="36" name="Rounded Rectangle 35"/>
+          <p:cNvSpPr/>
+          <p:nvPr/>
+        </p:nvSpPr>
+        <p:spPr>
+          <a:xfrm>
+            <a:off x="6446520" y="4983479"/>
+            <a:ext cx="1029800" cy="82296"/>
+          </a:xfrm>
+          <a:prstGeom prst="roundRect">
+            <a:avLst>
+              <a:gd name="adj" fmla="val 50000"/>
+            </a:avLst>
+          </a:prstGeom>
+          <a:solidFill>
+            <a:srgbClr val="5A369A"/>
+          </a:solidFill>
+          <a:ln>
+            <a:noFill/>
+          </a:ln>
+          <a:effectLst/>
+        </p:spPr>
+        <p:txBody>
+          <a:bodyPr rtlCol="0" anchor="ctr"/>
+          <a:lstStyle/>
+          <a:p>
+            <a:pPr algn="ctr"/>
+          </a:p>
+        </p:txBody>
+      </p:sp>
+      <p:sp>
+        <p:nvSpPr>
+          <p:cNvPr id="37" name="Rounded Rectangle 36"/>
+          <p:cNvSpPr/>
+          <p:nvPr/>
+        </p:nvSpPr>
+        <p:spPr>
+          <a:xfrm>
+            <a:off x="6446520" y="5321808"/>
+            <a:ext cx="5212080" cy="932688"/>
+          </a:xfrm>
+          <a:prstGeom prst="roundRect">
+            <a:avLst>
+              <a:gd name="adj" fmla="val 12000"/>
+            </a:avLst>
+          </a:prstGeom>
+          <a:solidFill>
+            <a:srgbClr val="F1EDFA"/>
+          </a:solidFill>
+          <a:ln>
+            <a:noFill/>
+          </a:ln>
+          <a:effectLst/>
+        </p:spPr>
+        <p:txBody>
+          <a:bodyPr rtlCol="0" anchor="ctr"/>
+          <a:lstStyle/>
+          <a:p>
+            <a:pPr algn="ctr"/>
+          </a:p>
+        </p:txBody>
+      </p:sp>
+      <p:sp>
+        <p:nvSpPr>
+          <p:cNvPr id="38" name="Oval 37"/>
+          <p:cNvSpPr/>
+          <p:nvPr/>
+        </p:nvSpPr>
+        <p:spPr>
+          <a:xfrm>
+            <a:off x="6629400" y="5513832"/>
+            <a:ext cx="548640" cy="548640"/>
+          </a:xfrm>
+          <a:prstGeom prst="ellipse">
+            <a:avLst/>
+          </a:prstGeom>
+          <a:solidFill>
+            <a:srgbClr val="512F8D"/>
+          </a:solidFill>
+          <a:ln>
+            <a:noFill/>
+          </a:ln>
+          <a:effectLst/>
+        </p:spPr>
+        <p:txBody>
+          <a:bodyPr rtlCol="0" anchor="ctr"/>
+          <a:lstStyle/>
+          <a:p>
+            <a:pPr algn="ctr"/>
+          </a:p>
+        </p:txBody>
+      </p:sp>
+      <p:pic>
+        <p:nvPicPr>
+          <p:cNvPr id="39" name="Picture 38" descr="layers-blanco.png"/>
+          <p:cNvPicPr>
+            <a:picLocks noChangeAspect="1"/>
+          </p:cNvPicPr>
+          <p:nvPr/>
+        </p:nvPicPr>
+        <p:blipFill>
+          <a:blip r:embed="rId4"/>
+          <a:stretch>
+            <a:fillRect/>
+          </a:stretch>
+        </p:blipFill>
+        <p:spPr>
+          <a:xfrm>
+            <a:off x="6752844" y="5637276"/>
+            <a:ext cx="301752" cy="301752"/>
+          </a:xfrm>
+          <a:prstGeom prst="rect">
+            <a:avLst/>
+          </a:prstGeom>
+        </p:spPr>
+      </p:pic>
+      <p:sp>
+        <p:nvSpPr>
+          <p:cNvPr id="40" name="TextBox 39"/>
+          <p:cNvSpPr txBox="1"/>
+          <p:nvPr/>
+        </p:nvSpPr>
+        <p:spPr>
+          <a:xfrm>
+            <a:off x="7315200" y="5431536"/>
+            <a:ext cx="4160520" cy="713232"/>
+          </a:xfrm>
+          <a:prstGeom prst="rect">
+            <a:avLst/>
+          </a:prstGeom>
+          <a:noFill/>
+        </p:spPr>
+        <p:txBody>
+          <a:bodyPr wrap="square" anchor="ctr" lIns="0" rIns="0" tIns="0" bIns="0">
+            <a:spAutoFit/>
+          </a:bodyPr>
+          <a:lstStyle/>
+          <a:p>
+            <a:pPr algn="l"/>
+            <a:r>
+              <a:rPr sz="1250" b="0">
+                <a:solidFill>
+                  <a:srgbClr val="20202B"/>
+                </a:solidFill>
+                <a:latin typeface="Calibri"/>
+              </a:rPr>
+              <a:t>La mitad de los beneficiarios se concentra en 31 de los 223 cantones con cobertura.</a:t>
+            </a:r>
+          </a:p>
+        </p:txBody>
+      </p:sp>
+      <p:sp>
+        <p:nvSpPr>
+          <p:cNvPr id="41" name="TextBox 40"/>
+          <p:cNvSpPr txBox="1"/>
+          <p:nvPr/>
+        </p:nvSpPr>
+        <p:spPr>
+          <a:xfrm>
+            <a:off x="502920" y="6473952"/>
+            <a:ext cx="9738359" cy="228600"/>
+          </a:xfrm>
+          <a:prstGeom prst="rect">
+            <a:avLst/>
+          </a:prstGeom>
+          <a:noFill/>
+        </p:spPr>
+        <p:txBody>
+          <a:bodyPr wrap="square" anchor="t" lIns="0" rIns="0" tIns="0" bIns="0">
+            <a:spAutoFit/>
+          </a:bodyPr>
+          <a:lstStyle/>
+          <a:p>
+            <a:pPr algn="l"/>
+            <a:r>
+              <a:rPr sz="950" b="0">
+                <a:solidFill>
+                  <a:srgbClr val="7A748B"/>
+                </a:solidFill>
+                <a:latin typeface="Calibri"/>
+              </a:rPr>
+              <a:t>Fuente: Ministerio de Trabajo y Desarrollo Humano · 23 de octubre de 2026</a:t>
+            </a:r>
+          </a:p>
+        </p:txBody>
+      </p:sp>
+      <p:sp>
+        <p:nvSpPr>
+          <p:cNvPr id="42" name="TextBox 41"/>
+          <p:cNvSpPr txBox="1"/>
+          <p:nvPr/>
+        </p:nvSpPr>
+        <p:spPr>
+          <a:xfrm>
+            <a:off x="10789920" y="6473952"/>
+            <a:ext cx="914400" cy="228600"/>
+          </a:xfrm>
+          <a:prstGeom prst="rect">
+            <a:avLst/>
+          </a:prstGeom>
+          <a:noFill/>
+        </p:spPr>
+        <p:txBody>
+          <a:bodyPr wrap="square" anchor="t" lIns="0" rIns="0" tIns="0" bIns="0">
+            <a:spAutoFit/>
+          </a:bodyPr>
+          <a:lstStyle/>
+          <a:p>
+            <a:pPr algn="r"/>
+            <a:r>
+              <a:rPr sz="950" b="0">
+                <a:solidFill>
+                  <a:srgbClr val="7A748B"/>
+                </a:solidFill>
+                <a:latin typeface="Calibri"/>
+              </a:rPr>
+              <a:t>3 / 6</a:t>
+            </a:r>
+          </a:p>
+        </p:txBody>
+      </p:sp>
+    </p:spTree>
+  </p:cSld>
+  <p:clrMapOvr>
+    <a:masterClrMapping/>
+  </p:clrMapOvr>
+</p:sld>
+</file>
+
+<file path=ppt/slides/slide4.xml><?xml version="1.0" encoding="utf-8"?>
+<p:sld xmlns:a="http://schemas.openxmlformats.org/drawingml/2006/main" xmlns:p="http://schemas.openxmlformats.org/presentationml/2006/main" xmlns:r="http://schemas.openxmlformats.org/officeDocument/2006/relationships">
+  <p:cSld>
+    <p:spTree>
+      <p:nvGrpSpPr>
+        <p:cNvPr id="1" name=""/>
+        <p:cNvGrpSpPr/>
+        <p:nvPr/>
+      </p:nvGrpSpPr>
+      <p:grpSpPr/>
+      <p:sp>
+        <p:nvSpPr>
+          <p:cNvPr id="2" name="Rectangle 1"/>
+          <p:cNvSpPr/>
+          <p:nvPr/>
+        </p:nvSpPr>
+        <p:spPr>
+          <a:xfrm>
+            <a:off x="0" y="0"/>
+            <a:ext cx="12191695" cy="1024128"/>
+          </a:xfrm>
+          <a:prstGeom prst="rect">
+            <a:avLst/>
+          </a:prstGeom>
+          <a:gradFill rotWithShape="1">
+            <a:gsLst>
+              <a:gs pos="0">
+                <a:srgbClr val="2B164F"/>
+              </a:gs>
+              <a:gs pos="100000">
+                <a:srgbClr val="512F8D"/>
+              </a:gs>
+            </a:gsLst>
+            <a:lin scaled="0" ang="0"/>
+          </a:gradFill>
+          <a:ln>
+            <a:noFill/>
+          </a:ln>
+          <a:effectLst/>
+        </p:spPr>
+        <p:txBody>
+          <a:bodyPr rtlCol="0" anchor="ctr"/>
+          <a:lstStyle/>
+          <a:p>
+            <a:pPr algn="ctr"/>
+          </a:p>
+        </p:txBody>
+      </p:sp>
+      <p:sp>
+        <p:nvSpPr>
+          <p:cNvPr id="3" name="Rectangle 2"/>
+          <p:cNvSpPr/>
+          <p:nvPr/>
+        </p:nvSpPr>
+        <p:spPr>
+          <a:xfrm>
+            <a:off x="0" y="1024128"/>
+            <a:ext cx="12191695" cy="54864"/>
+          </a:xfrm>
+          <a:prstGeom prst="rect">
+            <a:avLst/>
+          </a:prstGeom>
+          <a:solidFill>
+            <a:srgbClr val="F8C018"/>
+          </a:solidFill>
+          <a:ln>
+            <a:noFill/>
+          </a:ln>
+          <a:effectLst/>
+        </p:spPr>
+        <p:txBody>
+          <a:bodyPr rtlCol="0" anchor="ctr"/>
+          <a:lstStyle/>
+          <a:p>
+            <a:pPr algn="ctr"/>
+          </a:p>
+        </p:txBody>
+      </p:sp>
+      <p:sp>
+        <p:nvSpPr>
+          <p:cNvPr id="4" name="TextBox 3"/>
+          <p:cNvSpPr txBox="1"/>
+          <p:nvPr/>
+        </p:nvSpPr>
+        <p:spPr>
+          <a:xfrm>
+            <a:off x="502920" y="182880"/>
+            <a:ext cx="8595360" cy="502920"/>
+          </a:xfrm>
+          <a:prstGeom prst="rect">
+            <a:avLst/>
+          </a:prstGeom>
+          <a:noFill/>
+        </p:spPr>
+        <p:txBody>
+          <a:bodyPr wrap="square" anchor="t" lIns="0" rIns="0" tIns="0" bIns="0">
+            <a:spAutoFit/>
+          </a:bodyPr>
+          <a:lstStyle/>
+          <a:p>
+            <a:pPr algn="l"/>
+            <a:r>
+              <a:rPr sz="2600" b="1">
+                <a:solidFill>
+                  <a:srgbClr val="FFFFFF"/>
+                </a:solidFill>
+                <a:latin typeface="Century Gothic"/>
+              </a:rPr>
+              <a:t>Resultados por parroquia</a:t>
+            </a:r>
+          </a:p>
+        </p:txBody>
+      </p:sp>
+      <p:sp>
+        <p:nvSpPr>
+          <p:cNvPr id="5" name="TextBox 4"/>
+          <p:cNvSpPr txBox="1"/>
+          <p:nvPr/>
+        </p:nvSpPr>
+        <p:spPr>
+          <a:xfrm>
+            <a:off x="502920" y="640080"/>
+            <a:ext cx="8595360" cy="292608"/>
+          </a:xfrm>
+          <a:prstGeom prst="rect">
+            <a:avLst/>
+          </a:prstGeom>
+          <a:noFill/>
+        </p:spPr>
+        <p:txBody>
+          <a:bodyPr wrap="square" anchor="t" lIns="0" rIns="0" tIns="0" bIns="0">
+            <a:spAutoFit/>
+          </a:bodyPr>
+          <a:lstStyle/>
+          <a:p>
+            <a:pPr algn="l"/>
+            <a:r>
+              <a:rPr sz="1250" b="0">
+                <a:solidFill>
+                  <a:srgbClr val="E4DBF3"/>
+                </a:solidFill>
+                <a:latin typeface="Calibri"/>
+              </a:rPr>
+              <a:t>Beneficiarios · Septiembre 2026 · Nacional</a:t>
+            </a:r>
+          </a:p>
+        </p:txBody>
+      </p:sp>
+      <p:pic>
+        <p:nvPicPr>
+          <p:cNvPr id="6" name="Picture 5" descr="mtdh_logo.png"/>
+          <p:cNvPicPr>
+            <a:picLocks noChangeAspect="1"/>
+          </p:cNvPicPr>
+          <p:nvPr/>
+        </p:nvPicPr>
+        <p:blipFill>
+          <a:blip r:embed="rId2"/>
+          <a:stretch>
+            <a:fillRect/>
+          </a:stretch>
+        </p:blipFill>
+        <p:spPr>
+          <a:xfrm>
+            <a:off x="9372600" y="256032"/>
+            <a:ext cx="2380293" cy="566928"/>
+          </a:xfrm>
+          <a:prstGeom prst="rect">
+            <a:avLst/>
+          </a:prstGeom>
+        </p:spPr>
+      </p:pic>
+      <p:pic>
+        <p:nvPicPr>
+          <p:cNvPr id="7" name="Picture 6" descr="image.png"/>
+          <p:cNvPicPr>
+            <a:picLocks noChangeAspect="1"/>
+          </p:cNvPicPr>
+          <p:nvPr/>
+        </p:nvPicPr>
+        <p:blipFill>
+          <a:blip r:embed="rId3"/>
+          <a:stretch>
+            <a:fillRect/>
+          </a:stretch>
+        </p:blipFill>
+        <p:spPr>
+          <a:xfrm>
+            <a:off x="411480" y="1298448"/>
+            <a:ext cx="5638800" cy="5074920"/>
+          </a:xfrm>
+          <a:prstGeom prst="rect">
+            <a:avLst/>
+          </a:prstGeom>
+        </p:spPr>
+      </p:pic>
+      <p:sp>
+        <p:nvSpPr>
+          <p:cNvPr id="8" name="TextBox 7"/>
+          <p:cNvSpPr txBox="1"/>
+          <p:nvPr/>
+        </p:nvSpPr>
+        <p:spPr>
+          <a:xfrm>
+            <a:off x="6446520" y="1325880"/>
+            <a:ext cx="5212080" cy="365760"/>
+          </a:xfrm>
+          <a:prstGeom prst="rect">
+            <a:avLst/>
+          </a:prstGeom>
+          <a:noFill/>
+        </p:spPr>
+        <p:txBody>
+          <a:bodyPr wrap="square" anchor="t" lIns="0" rIns="0" tIns="0" bIns="0">
+            <a:spAutoFit/>
+          </a:bodyPr>
+          <a:lstStyle/>
+          <a:p>
+            <a:pPr algn="l"/>
+            <a:r>
+              <a:rPr sz="1800" b="1">
+                <a:solidFill>
+                  <a:srgbClr val="2B164F"/>
+                </a:solidFill>
+                <a:latin typeface="Century Gothic"/>
+              </a:rPr>
+              <a:t>Principales parroquias</a:t>
+            </a:r>
+          </a:p>
+        </p:txBody>
+      </p:sp>
+      <p:sp>
+        <p:nvSpPr>
+          <p:cNvPr id="9" name="TextBox 8"/>
+          <p:cNvSpPr txBox="1"/>
+          <p:nvPr/>
+        </p:nvSpPr>
+        <p:spPr>
+          <a:xfrm>
+            <a:off x="6446520" y="1828800"/>
+            <a:ext cx="3749039" cy="274320"/>
+          </a:xfrm>
+          <a:prstGeom prst="rect">
+            <a:avLst/>
+          </a:prstGeom>
+          <a:noFill/>
+        </p:spPr>
+        <p:txBody>
+          <a:bodyPr wrap="square" anchor="t" lIns="0" rIns="0" tIns="0" bIns="0">
+            <a:spAutoFit/>
+          </a:bodyPr>
+          <a:lstStyle/>
+          <a:p>
+            <a:pPr algn="l"/>
+            <a:r>
+              <a:rPr sz="1350" b="0">
+                <a:solidFill>
+                  <a:srgbClr val="20202B"/>
+                </a:solidFill>
+                <a:latin typeface="Calibri"/>
+              </a:rPr>
+              <a:t>1. Guayaquil</a:t>
+            </a:r>
+          </a:p>
+        </p:txBody>
+      </p:sp>
+      <p:sp>
+        <p:nvSpPr>
+          <p:cNvPr id="10" name="TextBox 9"/>
+          <p:cNvSpPr txBox="1"/>
+          <p:nvPr/>
+        </p:nvSpPr>
+        <p:spPr>
+          <a:xfrm>
+            <a:off x="9829800" y="1828800"/>
+            <a:ext cx="1828800" cy="274320"/>
+          </a:xfrm>
+          <a:prstGeom prst="rect">
+            <a:avLst/>
+          </a:prstGeom>
+          <a:noFill/>
+        </p:spPr>
+        <p:txBody>
+          <a:bodyPr wrap="square" anchor="t" lIns="0" rIns="0" tIns="0" bIns="0">
+            <a:spAutoFit/>
+          </a:bodyPr>
+          <a:lstStyle/>
+          <a:p>
+            <a:pPr algn="r"/>
+            <a:r>
+              <a:rPr sz="1350" b="1">
+                <a:solidFill>
+                  <a:srgbClr val="20202B"/>
+                </a:solidFill>
+                <a:latin typeface="Calibri"/>
+              </a:rPr>
+              <a:t>117.792</a:t>
+            </a:r>
+          </a:p>
+        </p:txBody>
+      </p:sp>
+      <p:sp>
+        <p:nvSpPr>
+          <p:cNvPr id="11" name="Rounded Rectangle 10"/>
+          <p:cNvSpPr/>
+          <p:nvPr/>
+        </p:nvSpPr>
+        <p:spPr>
+          <a:xfrm>
+            <a:off x="6446520" y="2130552"/>
+            <a:ext cx="5212080" cy="82296"/>
+          </a:xfrm>
+          <a:prstGeom prst="roundRect">
+            <a:avLst>
+              <a:gd name="adj" fmla="val 50000"/>
+            </a:avLst>
+          </a:prstGeom>
+          <a:solidFill>
+            <a:srgbClr val="EFECF5"/>
+          </a:solidFill>
+          <a:ln>
+            <a:noFill/>
+          </a:ln>
+          <a:effectLst/>
+        </p:spPr>
+        <p:txBody>
+          <a:bodyPr rtlCol="0" anchor="ctr"/>
+          <a:lstStyle/>
+          <a:p>
+            <a:pPr algn="ctr"/>
+          </a:p>
+        </p:txBody>
+      </p:sp>
+      <p:sp>
+        <p:nvSpPr>
+          <p:cNvPr id="12" name="Rounded Rectangle 11"/>
+          <p:cNvSpPr/>
+          <p:nvPr/>
+        </p:nvSpPr>
+        <p:spPr>
+          <a:xfrm>
+            <a:off x="6446520" y="2130552"/>
+            <a:ext cx="5212080" cy="82296"/>
+          </a:xfrm>
+          <a:prstGeom prst="roundRect">
+            <a:avLst>
+              <a:gd name="adj" fmla="val 50000"/>
+            </a:avLst>
+          </a:prstGeom>
+          <a:solidFill>
+            <a:srgbClr val="5A369A"/>
+          </a:solidFill>
+          <a:ln>
+            <a:noFill/>
+          </a:ln>
+          <a:effectLst/>
+        </p:spPr>
+        <p:txBody>
+          <a:bodyPr rtlCol="0" anchor="ctr"/>
+          <a:lstStyle/>
+          <a:p>
+            <a:pPr algn="ctr"/>
+          </a:p>
+        </p:txBody>
+      </p:sp>
+      <p:sp>
+        <p:nvSpPr>
+          <p:cNvPr id="13" name="TextBox 12"/>
+          <p:cNvSpPr txBox="1"/>
+          <p:nvPr/>
+        </p:nvSpPr>
+        <p:spPr>
+          <a:xfrm>
+            <a:off x="6446520" y="2304288"/>
+            <a:ext cx="3749039" cy="274320"/>
+          </a:xfrm>
+          <a:prstGeom prst="rect">
+            <a:avLst/>
+          </a:prstGeom>
+          <a:noFill/>
+        </p:spPr>
+        <p:txBody>
+          <a:bodyPr wrap="square" anchor="t" lIns="0" rIns="0" tIns="0" bIns="0">
+            <a:spAutoFit/>
+          </a:bodyPr>
+          <a:lstStyle/>
+          <a:p>
+            <a:pPr algn="l"/>
+            <a:r>
+              <a:rPr sz="1350" b="0">
+                <a:solidFill>
+                  <a:srgbClr val="20202B"/>
+                </a:solidFill>
+                <a:latin typeface="Calibri"/>
+              </a:rPr>
+              <a:t>2. Quito</a:t>
+            </a:r>
+          </a:p>
+        </p:txBody>
+      </p:sp>
+      <p:sp>
+        <p:nvSpPr>
+          <p:cNvPr id="14" name="TextBox 13"/>
+          <p:cNvSpPr txBox="1"/>
+          <p:nvPr/>
+        </p:nvSpPr>
+        <p:spPr>
+          <a:xfrm>
+            <a:off x="9829800" y="2304288"/>
+            <a:ext cx="1828800" cy="274320"/>
+          </a:xfrm>
+          <a:prstGeom prst="rect">
+            <a:avLst/>
+          </a:prstGeom>
+          <a:noFill/>
+        </p:spPr>
+        <p:txBody>
+          <a:bodyPr wrap="square" anchor="t" lIns="0" rIns="0" tIns="0" bIns="0">
+            <a:spAutoFit/>
+          </a:bodyPr>
+          <a:lstStyle/>
+          <a:p>
+            <a:pPr algn="r"/>
+            <a:r>
+              <a:rPr sz="1350" b="1">
+                <a:solidFill>
+                  <a:srgbClr val="20202B"/>
+                </a:solidFill>
+                <a:latin typeface="Calibri"/>
+              </a:rPr>
+              <a:t>40.295</a:t>
+            </a:r>
+          </a:p>
+        </p:txBody>
+      </p:sp>
+      <p:sp>
+        <p:nvSpPr>
+          <p:cNvPr id="15" name="Rounded Rectangle 14"/>
+          <p:cNvSpPr/>
+          <p:nvPr/>
+        </p:nvSpPr>
+        <p:spPr>
+          <a:xfrm>
+            <a:off x="6446520" y="2606040"/>
+            <a:ext cx="5212080" cy="82296"/>
+          </a:xfrm>
+          <a:prstGeom prst="roundRect">
+            <a:avLst>
+              <a:gd name="adj" fmla="val 50000"/>
+            </a:avLst>
+          </a:prstGeom>
+          <a:solidFill>
+            <a:srgbClr val="EFECF5"/>
+          </a:solidFill>
+          <a:ln>
+            <a:noFill/>
+          </a:ln>
+          <a:effectLst/>
+        </p:spPr>
+        <p:txBody>
+          <a:bodyPr rtlCol="0" anchor="ctr"/>
+          <a:lstStyle/>
+          <a:p>
+            <a:pPr algn="ctr"/>
+          </a:p>
+        </p:txBody>
+      </p:sp>
+      <p:sp>
+        <p:nvSpPr>
+          <p:cNvPr id="16" name="Rounded Rectangle 15"/>
+          <p:cNvSpPr/>
+          <p:nvPr/>
+        </p:nvSpPr>
+        <p:spPr>
+          <a:xfrm>
+            <a:off x="6446520" y="2606040"/>
+            <a:ext cx="1782979" cy="82296"/>
+          </a:xfrm>
+          <a:prstGeom prst="roundRect">
+            <a:avLst>
+              <a:gd name="adj" fmla="val 50000"/>
+            </a:avLst>
+          </a:prstGeom>
+          <a:solidFill>
+            <a:srgbClr val="5A369A"/>
+          </a:solidFill>
+          <a:ln>
+            <a:noFill/>
+          </a:ln>
+          <a:effectLst/>
+        </p:spPr>
+        <p:txBody>
+          <a:bodyPr rtlCol="0" anchor="ctr"/>
+          <a:lstStyle/>
+          <a:p>
+            <a:pPr algn="ctr"/>
+          </a:p>
+        </p:txBody>
+      </p:sp>
+      <p:sp>
+        <p:nvSpPr>
+          <p:cNvPr id="17" name="TextBox 16"/>
+          <p:cNvSpPr txBox="1"/>
+          <p:nvPr/>
+        </p:nvSpPr>
+        <p:spPr>
+          <a:xfrm>
+            <a:off x="6446520" y="2779776"/>
+            <a:ext cx="3749039" cy="274320"/>
+          </a:xfrm>
+          <a:prstGeom prst="rect">
+            <a:avLst/>
+          </a:prstGeom>
+          <a:noFill/>
+        </p:spPr>
+        <p:txBody>
+          <a:bodyPr wrap="square" anchor="t" lIns="0" rIns="0" tIns="0" bIns="0">
+            <a:spAutoFit/>
+          </a:bodyPr>
+          <a:lstStyle/>
+          <a:p>
+            <a:pPr algn="l"/>
+            <a:r>
+              <a:rPr sz="1350" b="0">
+                <a:solidFill>
+                  <a:srgbClr val="20202B"/>
+                </a:solidFill>
+                <a:latin typeface="Calibri"/>
+              </a:rPr>
+              <a:t>3. Santo Domingo de los Colorados</a:t>
+            </a:r>
+          </a:p>
+        </p:txBody>
+      </p:sp>
+      <p:sp>
+        <p:nvSpPr>
+          <p:cNvPr id="18" name="TextBox 17"/>
+          <p:cNvSpPr txBox="1"/>
+          <p:nvPr/>
+        </p:nvSpPr>
+        <p:spPr>
+          <a:xfrm>
+            <a:off x="9829800" y="2779776"/>
+            <a:ext cx="1828800" cy="274320"/>
+          </a:xfrm>
+          <a:prstGeom prst="rect">
+            <a:avLst/>
+          </a:prstGeom>
+          <a:noFill/>
+        </p:spPr>
+        <p:txBody>
+          <a:bodyPr wrap="square" anchor="t" lIns="0" rIns="0" tIns="0" bIns="0">
+            <a:spAutoFit/>
+          </a:bodyPr>
+          <a:lstStyle/>
+          <a:p>
+            <a:pPr algn="r"/>
+            <a:r>
+              <a:rPr sz="1350" b="1">
+                <a:solidFill>
+                  <a:srgbClr val="20202B"/>
+                </a:solidFill>
+                <a:latin typeface="Calibri"/>
+              </a:rPr>
+              <a:t>26.997</a:t>
+            </a:r>
+          </a:p>
+        </p:txBody>
+      </p:sp>
+      <p:sp>
+        <p:nvSpPr>
+          <p:cNvPr id="19" name="Rounded Rectangle 18"/>
+          <p:cNvSpPr/>
+          <p:nvPr/>
+        </p:nvSpPr>
+        <p:spPr>
+          <a:xfrm>
+            <a:off x="6446520" y="3081528"/>
+            <a:ext cx="5212080" cy="82296"/>
+          </a:xfrm>
+          <a:prstGeom prst="roundRect">
+            <a:avLst>
+              <a:gd name="adj" fmla="val 50000"/>
+            </a:avLst>
+          </a:prstGeom>
+          <a:solidFill>
+            <a:srgbClr val="EFECF5"/>
+          </a:solidFill>
+          <a:ln>
+            <a:noFill/>
+          </a:ln>
+          <a:effectLst/>
+        </p:spPr>
+        <p:txBody>
+          <a:bodyPr rtlCol="0" anchor="ctr"/>
+          <a:lstStyle/>
+          <a:p>
+            <a:pPr algn="ctr"/>
+          </a:p>
+        </p:txBody>
+      </p:sp>
+      <p:sp>
+        <p:nvSpPr>
+          <p:cNvPr id="20" name="Rounded Rectangle 19"/>
+          <p:cNvSpPr/>
+          <p:nvPr/>
+        </p:nvSpPr>
+        <p:spPr>
+          <a:xfrm>
+            <a:off x="6446520" y="3081528"/>
+            <a:ext cx="1194567" cy="82296"/>
+          </a:xfrm>
+          <a:prstGeom prst="roundRect">
+            <a:avLst>
+              <a:gd name="adj" fmla="val 50000"/>
+            </a:avLst>
+          </a:prstGeom>
+          <a:solidFill>
+            <a:srgbClr val="5A369A"/>
+          </a:solidFill>
+          <a:ln>
+            <a:noFill/>
+          </a:ln>
+          <a:effectLst/>
+        </p:spPr>
+        <p:txBody>
+          <a:bodyPr rtlCol="0" anchor="ctr"/>
+          <a:lstStyle/>
+          <a:p>
+            <a:pPr algn="ctr"/>
+          </a:p>
+        </p:txBody>
+      </p:sp>
+      <p:sp>
+        <p:nvSpPr>
+          <p:cNvPr id="21" name="TextBox 20"/>
+          <p:cNvSpPr txBox="1"/>
+          <p:nvPr/>
+        </p:nvSpPr>
+        <p:spPr>
+          <a:xfrm>
+            <a:off x="6446520" y="3255264"/>
+            <a:ext cx="3749039" cy="274320"/>
+          </a:xfrm>
+          <a:prstGeom prst="rect">
+            <a:avLst/>
+          </a:prstGeom>
+          <a:noFill/>
+        </p:spPr>
+        <p:txBody>
+          <a:bodyPr wrap="square" anchor="t" lIns="0" rIns="0" tIns="0" bIns="0">
+            <a:spAutoFit/>
+          </a:bodyPr>
+          <a:lstStyle/>
+          <a:p>
+            <a:pPr algn="l"/>
+            <a:r>
+              <a:rPr sz="1350" b="0">
+                <a:solidFill>
+                  <a:srgbClr val="20202B"/>
+                </a:solidFill>
+                <a:latin typeface="Calibri"/>
+              </a:rPr>
+              <a:t>4. Esmeraldas</a:t>
+            </a:r>
+          </a:p>
+        </p:txBody>
+      </p:sp>
+      <p:sp>
+        <p:nvSpPr>
+          <p:cNvPr id="22" name="TextBox 21"/>
+          <p:cNvSpPr txBox="1"/>
+          <p:nvPr/>
+        </p:nvSpPr>
+        <p:spPr>
+          <a:xfrm>
+            <a:off x="9829800" y="3255264"/>
+            <a:ext cx="1828800" cy="274320"/>
+          </a:xfrm>
+          <a:prstGeom prst="rect">
+            <a:avLst/>
+          </a:prstGeom>
+          <a:noFill/>
+        </p:spPr>
+        <p:txBody>
+          <a:bodyPr wrap="square" anchor="t" lIns="0" rIns="0" tIns="0" bIns="0">
+            <a:spAutoFit/>
+          </a:bodyPr>
+          <a:lstStyle/>
+          <a:p>
+            <a:pPr algn="r"/>
+            <a:r>
+              <a:rPr sz="1350" b="1">
+                <a:solidFill>
+                  <a:srgbClr val="20202B"/>
+                </a:solidFill>
+                <a:latin typeface="Calibri"/>
+              </a:rPr>
+              <a:t>20.022</a:t>
+            </a:r>
+          </a:p>
+        </p:txBody>
+      </p:sp>
+      <p:sp>
+        <p:nvSpPr>
+          <p:cNvPr id="23" name="Rounded Rectangle 22"/>
+          <p:cNvSpPr/>
+          <p:nvPr/>
+        </p:nvSpPr>
+        <p:spPr>
+          <a:xfrm>
+            <a:off x="6446520" y="3557016"/>
+            <a:ext cx="5212080" cy="82296"/>
+          </a:xfrm>
+          <a:prstGeom prst="roundRect">
+            <a:avLst>
+              <a:gd name="adj" fmla="val 50000"/>
+            </a:avLst>
+          </a:prstGeom>
+          <a:solidFill>
+            <a:srgbClr val="EFECF5"/>
+          </a:solidFill>
+          <a:ln>
+            <a:noFill/>
+          </a:ln>
+          <a:effectLst/>
+        </p:spPr>
+        <p:txBody>
+          <a:bodyPr rtlCol="0" anchor="ctr"/>
+          <a:lstStyle/>
+          <a:p>
+            <a:pPr algn="ctr"/>
+          </a:p>
+        </p:txBody>
+      </p:sp>
+      <p:sp>
+        <p:nvSpPr>
+          <p:cNvPr id="24" name="Rounded Rectangle 23"/>
+          <p:cNvSpPr/>
+          <p:nvPr/>
+        </p:nvSpPr>
+        <p:spPr>
+          <a:xfrm>
+            <a:off x="6446520" y="3557016"/>
+            <a:ext cx="885936" cy="82296"/>
+          </a:xfrm>
+          <a:prstGeom prst="roundRect">
+            <a:avLst>
+              <a:gd name="adj" fmla="val 50000"/>
+            </a:avLst>
+          </a:prstGeom>
+          <a:solidFill>
+            <a:srgbClr val="5A369A"/>
+          </a:solidFill>
+          <a:ln>
+            <a:noFill/>
+          </a:ln>
+          <a:effectLst/>
+        </p:spPr>
+        <p:txBody>
+          <a:bodyPr rtlCol="0" anchor="ctr"/>
+          <a:lstStyle/>
+          <a:p>
+            <a:pPr algn="ctr"/>
+          </a:p>
+        </p:txBody>
+      </p:sp>
+      <p:sp>
+        <p:nvSpPr>
+          <p:cNvPr id="25" name="TextBox 24"/>
+          <p:cNvSpPr txBox="1"/>
+          <p:nvPr/>
+        </p:nvSpPr>
+        <p:spPr>
+          <a:xfrm>
+            <a:off x="6446520" y="3730752"/>
+            <a:ext cx="3749039" cy="274320"/>
+          </a:xfrm>
+          <a:prstGeom prst="rect">
+            <a:avLst/>
+          </a:prstGeom>
+          <a:noFill/>
+        </p:spPr>
+        <p:txBody>
+          <a:bodyPr wrap="square" anchor="t" lIns="0" rIns="0" tIns="0" bIns="0">
+            <a:spAutoFit/>
+          </a:bodyPr>
+          <a:lstStyle/>
+          <a:p>
+            <a:pPr algn="l"/>
+            <a:r>
+              <a:rPr sz="1350" b="0">
+                <a:solidFill>
+                  <a:srgbClr val="20202B"/>
+                </a:solidFill>
+                <a:latin typeface="Calibri"/>
+              </a:rPr>
+              <a:t>5. Eloy Alfaro · Durán</a:t>
+            </a:r>
+          </a:p>
+        </p:txBody>
+      </p:sp>
+      <p:sp>
+        <p:nvSpPr>
+          <p:cNvPr id="26" name="TextBox 25"/>
+          <p:cNvSpPr txBox="1"/>
+          <p:nvPr/>
+        </p:nvSpPr>
+        <p:spPr>
+          <a:xfrm>
+            <a:off x="9829800" y="3730752"/>
+            <a:ext cx="1828800" cy="274320"/>
+          </a:xfrm>
+          <a:prstGeom prst="rect">
+            <a:avLst/>
+          </a:prstGeom>
+          <a:noFill/>
+        </p:spPr>
+        <p:txBody>
+          <a:bodyPr wrap="square" anchor="t" lIns="0" rIns="0" tIns="0" bIns="0">
+            <a:spAutoFit/>
+          </a:bodyPr>
+          <a:lstStyle/>
+          <a:p>
+            <a:pPr algn="r"/>
+            <a:r>
+              <a:rPr sz="1350" b="1">
+                <a:solidFill>
+                  <a:srgbClr val="20202B"/>
+                </a:solidFill>
+                <a:latin typeface="Calibri"/>
+              </a:rPr>
+              <a:t>18.193</a:t>
+            </a:r>
+          </a:p>
+        </p:txBody>
+      </p:sp>
+      <p:sp>
+        <p:nvSpPr>
+          <p:cNvPr id="27" name="Rounded Rectangle 26"/>
+          <p:cNvSpPr/>
+          <p:nvPr/>
+        </p:nvSpPr>
+        <p:spPr>
+          <a:xfrm>
+            <a:off x="6446520" y="4032504"/>
+            <a:ext cx="5212080" cy="82296"/>
+          </a:xfrm>
+          <a:prstGeom prst="roundRect">
+            <a:avLst>
+              <a:gd name="adj" fmla="val 50000"/>
+            </a:avLst>
+          </a:prstGeom>
+          <a:solidFill>
+            <a:srgbClr val="EFECF5"/>
+          </a:solidFill>
+          <a:ln>
+            <a:noFill/>
+          </a:ln>
+          <a:effectLst/>
+        </p:spPr>
+        <p:txBody>
+          <a:bodyPr rtlCol="0" anchor="ctr"/>
+          <a:lstStyle/>
+          <a:p>
+            <a:pPr algn="ctr"/>
+          </a:p>
+        </p:txBody>
+      </p:sp>
+      <p:sp>
+        <p:nvSpPr>
+          <p:cNvPr id="28" name="Rounded Rectangle 27"/>
+          <p:cNvSpPr/>
+          <p:nvPr/>
+        </p:nvSpPr>
+        <p:spPr>
+          <a:xfrm>
+            <a:off x="6446520" y="4032504"/>
+            <a:ext cx="805006" cy="82296"/>
+          </a:xfrm>
+          <a:prstGeom prst="roundRect">
+            <a:avLst>
+              <a:gd name="adj" fmla="val 50000"/>
+            </a:avLst>
+          </a:prstGeom>
+          <a:solidFill>
+            <a:srgbClr val="5A369A"/>
+          </a:solidFill>
+          <a:ln>
+            <a:noFill/>
+          </a:ln>
+          <a:effectLst/>
+        </p:spPr>
+        <p:txBody>
+          <a:bodyPr rtlCol="0" anchor="ctr"/>
+          <a:lstStyle/>
+          <a:p>
+            <a:pPr algn="ctr"/>
+          </a:p>
+        </p:txBody>
+      </p:sp>
+      <p:sp>
+        <p:nvSpPr>
+          <p:cNvPr id="29" name="TextBox 28"/>
+          <p:cNvSpPr txBox="1"/>
+          <p:nvPr/>
+        </p:nvSpPr>
+        <p:spPr>
+          <a:xfrm>
+            <a:off x="6446520" y="4206240"/>
+            <a:ext cx="3749039" cy="274320"/>
+          </a:xfrm>
+          <a:prstGeom prst="rect">
+            <a:avLst/>
+          </a:prstGeom>
+          <a:noFill/>
+        </p:spPr>
+        <p:txBody>
+          <a:bodyPr wrap="square" anchor="t" lIns="0" rIns="0" tIns="0" bIns="0">
+            <a:spAutoFit/>
+          </a:bodyPr>
+          <a:lstStyle/>
+          <a:p>
+            <a:pPr algn="l"/>
+            <a:r>
+              <a:rPr sz="1350" b="0">
+                <a:solidFill>
+                  <a:srgbClr val="20202B"/>
+                </a:solidFill>
+                <a:latin typeface="Calibri"/>
+              </a:rPr>
+              <a:t>6. Quevedo</a:t>
+            </a:r>
+          </a:p>
+        </p:txBody>
+      </p:sp>
+      <p:sp>
+        <p:nvSpPr>
+          <p:cNvPr id="30" name="TextBox 29"/>
+          <p:cNvSpPr txBox="1"/>
+          <p:nvPr/>
+        </p:nvSpPr>
+        <p:spPr>
+          <a:xfrm>
+            <a:off x="9829800" y="4206240"/>
+            <a:ext cx="1828800" cy="274320"/>
+          </a:xfrm>
+          <a:prstGeom prst="rect">
+            <a:avLst/>
+          </a:prstGeom>
+          <a:noFill/>
+        </p:spPr>
+        <p:txBody>
+          <a:bodyPr wrap="square" anchor="t" lIns="0" rIns="0" tIns="0" bIns="0">
+            <a:spAutoFit/>
+          </a:bodyPr>
+          <a:lstStyle/>
+          <a:p>
+            <a:pPr algn="r"/>
+            <a:r>
+              <a:rPr sz="1350" b="1">
+                <a:solidFill>
+                  <a:srgbClr val="20202B"/>
+                </a:solidFill>
+                <a:latin typeface="Calibri"/>
+              </a:rPr>
+              <a:t>17.477</a:t>
+            </a:r>
+          </a:p>
+        </p:txBody>
+      </p:sp>
+      <p:sp>
+        <p:nvSpPr>
+          <p:cNvPr id="31" name="Rounded Rectangle 30"/>
+          <p:cNvSpPr/>
+          <p:nvPr/>
+        </p:nvSpPr>
+        <p:spPr>
+          <a:xfrm>
+            <a:off x="6446520" y="4507992"/>
+            <a:ext cx="5212080" cy="82296"/>
+          </a:xfrm>
+          <a:prstGeom prst="roundRect">
+            <a:avLst>
+              <a:gd name="adj" fmla="val 50000"/>
+            </a:avLst>
+          </a:prstGeom>
+          <a:solidFill>
+            <a:srgbClr val="EFECF5"/>
+          </a:solidFill>
+          <a:ln>
+            <a:noFill/>
+          </a:ln>
+          <a:effectLst/>
+        </p:spPr>
+        <p:txBody>
+          <a:bodyPr rtlCol="0" anchor="ctr"/>
+          <a:lstStyle/>
+          <a:p>
+            <a:pPr algn="ctr"/>
+          </a:p>
+        </p:txBody>
+      </p:sp>
+      <p:sp>
+        <p:nvSpPr>
+          <p:cNvPr id="32" name="Rounded Rectangle 31"/>
+          <p:cNvSpPr/>
+          <p:nvPr/>
+        </p:nvSpPr>
+        <p:spPr>
+          <a:xfrm>
+            <a:off x="6446520" y="4507992"/>
+            <a:ext cx="773325" cy="82296"/>
+          </a:xfrm>
+          <a:prstGeom prst="roundRect">
+            <a:avLst>
+              <a:gd name="adj" fmla="val 50000"/>
+            </a:avLst>
+          </a:prstGeom>
+          <a:solidFill>
+            <a:srgbClr val="5A369A"/>
+          </a:solidFill>
+          <a:ln>
+            <a:noFill/>
+          </a:ln>
+          <a:effectLst/>
+        </p:spPr>
+        <p:txBody>
+          <a:bodyPr rtlCol="0" anchor="ctr"/>
+          <a:lstStyle/>
+          <a:p>
+            <a:pPr algn="ctr"/>
+          </a:p>
+        </p:txBody>
+      </p:sp>
+      <p:sp>
+        <p:nvSpPr>
+          <p:cNvPr id="33" name="TextBox 32"/>
+          <p:cNvSpPr txBox="1"/>
+          <p:nvPr/>
+        </p:nvSpPr>
+        <p:spPr>
+          <a:xfrm>
+            <a:off x="6446520" y="4681727"/>
+            <a:ext cx="3749039" cy="274320"/>
+          </a:xfrm>
+          <a:prstGeom prst="rect">
+            <a:avLst/>
+          </a:prstGeom>
+          <a:noFill/>
+        </p:spPr>
+        <p:txBody>
+          <a:bodyPr wrap="square" anchor="t" lIns="0" rIns="0" tIns="0" bIns="0">
+            <a:spAutoFit/>
+          </a:bodyPr>
+          <a:lstStyle/>
+          <a:p>
+            <a:pPr algn="l"/>
+            <a:r>
+              <a:rPr sz="1350" b="0">
+                <a:solidFill>
+                  <a:srgbClr val="20202B"/>
+                </a:solidFill>
+                <a:latin typeface="Calibri"/>
+              </a:rPr>
+              <a:t>7. Portoviejo</a:t>
+            </a:r>
+          </a:p>
+        </p:txBody>
+      </p:sp>
+      <p:sp>
+        <p:nvSpPr>
+          <p:cNvPr id="34" name="TextBox 33"/>
+          <p:cNvSpPr txBox="1"/>
+          <p:nvPr/>
+        </p:nvSpPr>
+        <p:spPr>
+          <a:xfrm>
+            <a:off x="9829800" y="4681727"/>
+            <a:ext cx="1828800" cy="274320"/>
+          </a:xfrm>
+          <a:prstGeom prst="rect">
+            <a:avLst/>
+          </a:prstGeom>
+          <a:noFill/>
+        </p:spPr>
+        <p:txBody>
+          <a:bodyPr wrap="square" anchor="t" lIns="0" rIns="0" tIns="0" bIns="0">
+            <a:spAutoFit/>
+          </a:bodyPr>
+          <a:lstStyle/>
+          <a:p>
+            <a:pPr algn="r"/>
+            <a:r>
+              <a:rPr sz="1350" b="1">
+                <a:solidFill>
+                  <a:srgbClr val="20202B"/>
+                </a:solidFill>
+                <a:latin typeface="Calibri"/>
+              </a:rPr>
+              <a:t>17.107</a:t>
+            </a:r>
+          </a:p>
+        </p:txBody>
+      </p:sp>
+      <p:sp>
+        <p:nvSpPr>
+          <p:cNvPr id="35" name="Rounded Rectangle 34"/>
+          <p:cNvSpPr/>
+          <p:nvPr/>
+        </p:nvSpPr>
+        <p:spPr>
+          <a:xfrm>
+            <a:off x="6446520" y="4983479"/>
+            <a:ext cx="5212080" cy="82296"/>
+          </a:xfrm>
+          <a:prstGeom prst="roundRect">
+            <a:avLst>
+              <a:gd name="adj" fmla="val 50000"/>
+            </a:avLst>
+          </a:prstGeom>
+          <a:solidFill>
+            <a:srgbClr val="EFECF5"/>
+          </a:solidFill>
+          <a:ln>
+            <a:noFill/>
+          </a:ln>
+          <a:effectLst/>
+        </p:spPr>
+        <p:txBody>
+          <a:bodyPr rtlCol="0" anchor="ctr"/>
+          <a:lstStyle/>
+          <a:p>
+            <a:pPr algn="ctr"/>
+          </a:p>
+        </p:txBody>
+      </p:sp>
+      <p:sp>
+        <p:nvSpPr>
+          <p:cNvPr id="36" name="Rounded Rectangle 35"/>
+          <p:cNvSpPr/>
+          <p:nvPr/>
+        </p:nvSpPr>
+        <p:spPr>
+          <a:xfrm>
+            <a:off x="6446520" y="4983479"/>
+            <a:ext cx="756953" cy="82296"/>
+          </a:xfrm>
+          <a:prstGeom prst="roundRect">
+            <a:avLst>
+              <a:gd name="adj" fmla="val 50000"/>
+            </a:avLst>
+          </a:prstGeom>
+          <a:solidFill>
+            <a:srgbClr val="5A369A"/>
+          </a:solidFill>
+          <a:ln>
+            <a:noFill/>
+          </a:ln>
+          <a:effectLst/>
+        </p:spPr>
+        <p:txBody>
+          <a:bodyPr rtlCol="0" anchor="ctr"/>
+          <a:lstStyle/>
+          <a:p>
+            <a:pPr algn="ctr"/>
+          </a:p>
+        </p:txBody>
+      </p:sp>
+      <p:sp>
+        <p:nvSpPr>
+          <p:cNvPr id="37" name="Rounded Rectangle 36"/>
+          <p:cNvSpPr/>
+          <p:nvPr/>
+        </p:nvSpPr>
+        <p:spPr>
+          <a:xfrm>
+            <a:off x="6446520" y="5321808"/>
+            <a:ext cx="5212080" cy="932688"/>
+          </a:xfrm>
+          <a:prstGeom prst="roundRect">
+            <a:avLst>
+              <a:gd name="adj" fmla="val 12000"/>
+            </a:avLst>
+          </a:prstGeom>
+          <a:solidFill>
+            <a:srgbClr val="F1EDFA"/>
+          </a:solidFill>
+          <a:ln>
+            <a:noFill/>
+          </a:ln>
+          <a:effectLst/>
+        </p:spPr>
+        <p:txBody>
+          <a:bodyPr rtlCol="0" anchor="ctr"/>
+          <a:lstStyle/>
+          <a:p>
+            <a:pPr algn="ctr"/>
+          </a:p>
+        </p:txBody>
+      </p:sp>
+      <p:sp>
+        <p:nvSpPr>
+          <p:cNvPr id="38" name="Oval 37"/>
+          <p:cNvSpPr/>
+          <p:nvPr/>
+        </p:nvSpPr>
+        <p:spPr>
+          <a:xfrm>
+            <a:off x="6629400" y="5513832"/>
+            <a:ext cx="548640" cy="548640"/>
+          </a:xfrm>
+          <a:prstGeom prst="ellipse">
+            <a:avLst/>
+          </a:prstGeom>
+          <a:solidFill>
+            <a:srgbClr val="512F8D"/>
+          </a:solidFill>
+          <a:ln>
+            <a:noFill/>
+          </a:ln>
+          <a:effectLst/>
+        </p:spPr>
+        <p:txBody>
+          <a:bodyPr rtlCol="0" anchor="ctr"/>
+          <a:lstStyle/>
+          <a:p>
+            <a:pPr algn="ctr"/>
+          </a:p>
+        </p:txBody>
+      </p:sp>
+      <p:pic>
+        <p:nvPicPr>
+          <p:cNvPr id="39" name="Picture 38" descr="layers-blanco.png"/>
+          <p:cNvPicPr>
+            <a:picLocks noChangeAspect="1"/>
+          </p:cNvPicPr>
+          <p:nvPr/>
+        </p:nvPicPr>
+        <p:blipFill>
+          <a:blip r:embed="rId4"/>
+          <a:stretch>
+            <a:fillRect/>
+          </a:stretch>
+        </p:blipFill>
+        <p:spPr>
+          <a:xfrm>
+            <a:off x="6752844" y="5637276"/>
+            <a:ext cx="301752" cy="301752"/>
+          </a:xfrm>
+          <a:prstGeom prst="rect">
+            <a:avLst/>
+          </a:prstGeom>
+        </p:spPr>
+      </p:pic>
+      <p:sp>
+        <p:nvSpPr>
+          <p:cNvPr id="40" name="TextBox 39"/>
+          <p:cNvSpPr txBox="1"/>
+          <p:nvPr/>
+        </p:nvSpPr>
+        <p:spPr>
+          <a:xfrm>
+            <a:off x="7315200" y="5431536"/>
+            <a:ext cx="4160520" cy="713232"/>
+          </a:xfrm>
+          <a:prstGeom prst="rect">
+            <a:avLst/>
+          </a:prstGeom>
+          <a:noFill/>
+        </p:spPr>
+        <p:txBody>
+          <a:bodyPr wrap="square" anchor="ctr" lIns="0" rIns="0" tIns="0" bIns="0">
+            <a:spAutoFit/>
+          </a:bodyPr>
+          <a:lstStyle/>
+          <a:p>
+            <a:pPr algn="l"/>
+            <a:r>
+              <a:rPr sz="1250" b="0">
+                <a:solidFill>
+                  <a:srgbClr val="20202B"/>
+                </a:solidFill>
+                <a:latin typeface="Calibri"/>
+              </a:rPr>
+              <a:t>La mitad de los beneficiarios se concentra en 96 de las 1.283 parroquias con cobertura.</a:t>
+            </a:r>
+          </a:p>
+        </p:txBody>
+      </p:sp>
+      <p:sp>
+        <p:nvSpPr>
+          <p:cNvPr id="41" name="TextBox 40"/>
+          <p:cNvSpPr txBox="1"/>
+          <p:nvPr/>
+        </p:nvSpPr>
+        <p:spPr>
+          <a:xfrm>
+            <a:off x="502920" y="6473952"/>
+            <a:ext cx="9738359" cy="228600"/>
+          </a:xfrm>
+          <a:prstGeom prst="rect">
+            <a:avLst/>
+          </a:prstGeom>
+          <a:noFill/>
+        </p:spPr>
+        <p:txBody>
+          <a:bodyPr wrap="square" anchor="t" lIns="0" rIns="0" tIns="0" bIns="0">
+            <a:spAutoFit/>
+          </a:bodyPr>
+          <a:lstStyle/>
+          <a:p>
+            <a:pPr algn="l"/>
+            <a:r>
+              <a:rPr sz="950" b="0">
+                <a:solidFill>
+                  <a:srgbClr val="7A748B"/>
+                </a:solidFill>
+                <a:latin typeface="Calibri"/>
+              </a:rPr>
+              <a:t>Fuente: Ministerio de Trabajo y Desarrollo Humano · 23 de octubre de 2026</a:t>
+            </a:r>
+          </a:p>
+        </p:txBody>
+      </p:sp>
+      <p:sp>
+        <p:nvSpPr>
+          <p:cNvPr id="42" name="TextBox 41"/>
+          <p:cNvSpPr txBox="1"/>
+          <p:nvPr/>
+        </p:nvSpPr>
+        <p:spPr>
+          <a:xfrm>
+            <a:off x="10789920" y="6473952"/>
+            <a:ext cx="914400" cy="228600"/>
+          </a:xfrm>
+          <a:prstGeom prst="rect">
+            <a:avLst/>
+          </a:prstGeom>
+          <a:noFill/>
+        </p:spPr>
+        <p:txBody>
+          <a:bodyPr wrap="square" anchor="t" lIns="0" rIns="0" tIns="0" bIns="0">
+            <a:spAutoFit/>
+          </a:bodyPr>
+          <a:lstStyle/>
+          <a:p>
+            <a:pPr algn="r"/>
+            <a:r>
+              <a:rPr sz="950" b="0">
+                <a:solidFill>
+                  <a:srgbClr val="7A748B"/>
+                </a:solidFill>
+                <a:latin typeface="Calibri"/>
+              </a:rPr>
+              <a:t>4 / 6</a:t>
+            </a:r>
+          </a:p>
+        </p:txBody>
+      </p:sp>
+    </p:spTree>
+  </p:cSld>
+  <p:clrMapOvr>
+    <a:masterClrMapping/>
+  </p:clrMapOvr>
+</p:sld>
+</file>
+
+<file path=ppt/slides/slide5.xml><?xml version="1.0" encoding="utf-8"?>
+<p:sld xmlns:a="http://schemas.openxmlformats.org/drawingml/2006/main" xmlns:p="http://schemas.openxmlformats.org/presentationml/2006/main" xmlns:r="http://schemas.openxmlformats.org/officeDocument/2006/relationships">
+  <p:cSld>
+    <p:spTree>
+      <p:nvGrpSpPr>
+        <p:cNvPr id="1" name=""/>
+        <p:cNvGrpSpPr/>
+        <p:nvPr/>
+      </p:nvGrpSpPr>
+      <p:grpSpPr/>
+      <p:sp>
+        <p:nvSpPr>
+          <p:cNvPr id="2" name="Rectangle 1"/>
+          <p:cNvSpPr/>
+          <p:nvPr/>
+        </p:nvSpPr>
+        <p:spPr>
+          <a:xfrm>
+            <a:off x="0" y="0"/>
+            <a:ext cx="12191695" cy="1024128"/>
+          </a:xfrm>
+          <a:prstGeom prst="rect">
+            <a:avLst/>
+          </a:prstGeom>
+          <a:gradFill rotWithShape="1">
+            <a:gsLst>
+              <a:gs pos="0">
+                <a:srgbClr val="2B164F"/>
+              </a:gs>
+              <a:gs pos="100000">
+                <a:srgbClr val="512F8D"/>
+              </a:gs>
+            </a:gsLst>
+            <a:lin scaled="0" ang="0"/>
+          </a:gradFill>
+          <a:ln>
+            <a:noFill/>
+          </a:ln>
+          <a:effectLst/>
+        </p:spPr>
+        <p:txBody>
+          <a:bodyPr rtlCol="0" anchor="ctr"/>
+          <a:lstStyle/>
+          <a:p>
+            <a:pPr algn="ctr"/>
+          </a:p>
+        </p:txBody>
+      </p:sp>
+      <p:sp>
+        <p:nvSpPr>
+          <p:cNvPr id="3" name="Rectangle 2"/>
+          <p:cNvSpPr/>
+          <p:nvPr/>
+        </p:nvSpPr>
+        <p:spPr>
+          <a:xfrm>
+            <a:off x="0" y="1024128"/>
+            <a:ext cx="12191695" cy="54864"/>
+          </a:xfrm>
+          <a:prstGeom prst="rect">
+            <a:avLst/>
+          </a:prstGeom>
+          <a:solidFill>
+            <a:srgbClr val="F8C018"/>
+          </a:solidFill>
+          <a:ln>
+            <a:noFill/>
+          </a:ln>
+          <a:effectLst/>
+        </p:spPr>
+        <p:txBody>
+          <a:bodyPr rtlCol="0" anchor="ctr"/>
+          <a:lstStyle/>
+          <a:p>
+            <a:pPr algn="ctr"/>
+          </a:p>
+        </p:txBody>
+      </p:sp>
+      <p:sp>
+        <p:nvSpPr>
+          <p:cNvPr id="4" name="TextBox 3"/>
+          <p:cNvSpPr txBox="1"/>
+          <p:nvPr/>
+        </p:nvSpPr>
+        <p:spPr>
+          <a:xfrm>
+            <a:off x="502920" y="182880"/>
+            <a:ext cx="8595360" cy="502920"/>
+          </a:xfrm>
+          <a:prstGeom prst="rect">
+            <a:avLst/>
+          </a:prstGeom>
+          <a:noFill/>
+        </p:spPr>
+        <p:txBody>
+          <a:bodyPr wrap="square" anchor="t" lIns="0" rIns="0" tIns="0" bIns="0">
+            <a:spAutoFit/>
+          </a:bodyPr>
+          <a:lstStyle/>
+          <a:p>
+            <a:pPr algn="l"/>
+            <a:r>
+              <a:rPr sz="2600" b="1">
+                <a:solidFill>
+                  <a:srgbClr val="FFFFFF"/>
+                </a:solidFill>
+                <a:latin typeface="Century Gothic"/>
+              </a:rPr>
+              <a:t>Ejecución presupuestaria</a:t>
+            </a:r>
+          </a:p>
+        </p:txBody>
+      </p:sp>
+      <p:sp>
+        <p:nvSpPr>
+          <p:cNvPr id="5" name="TextBox 4"/>
+          <p:cNvSpPr txBox="1"/>
+          <p:nvPr/>
+        </p:nvSpPr>
+        <p:spPr>
+          <a:xfrm>
+            <a:off x="502920" y="640080"/>
+            <a:ext cx="8595360" cy="292608"/>
+          </a:xfrm>
+          <a:prstGeom prst="rect">
+            <a:avLst/>
+          </a:prstGeom>
+          <a:noFill/>
+        </p:spPr>
+        <p:txBody>
+          <a:bodyPr wrap="square" anchor="t" lIns="0" rIns="0" tIns="0" bIns="0">
+            <a:spAutoFit/>
+          </a:bodyPr>
+          <a:lstStyle/>
+          <a:p>
+            <a:pPr algn="l"/>
+            <a:r>
+              <a:rPr sz="1250" b="0">
+                <a:solidFill>
+                  <a:srgbClr val="E4DBF3"/>
+                </a:solidFill>
+                <a:latin typeface="Calibri"/>
+              </a:rPr>
+              <a:t>Devengado sobre codificado · Septiembre 2026 · Nacional</a:t>
+            </a:r>
+          </a:p>
+        </p:txBody>
+      </p:sp>
+      <p:pic>
+        <p:nvPicPr>
+          <p:cNvPr id="6" name="Picture 5" descr="mtdh_logo.png"/>
+          <p:cNvPicPr>
+            <a:picLocks noChangeAspect="1"/>
+          </p:cNvPicPr>
+          <p:nvPr/>
+        </p:nvPicPr>
+        <p:blipFill>
+          <a:blip r:embed="rId2"/>
+          <a:stretch>
+            <a:fillRect/>
+          </a:stretch>
+        </p:blipFill>
+        <p:spPr>
+          <a:xfrm>
+            <a:off x="9372600" y="256032"/>
+            <a:ext cx="2380293" cy="566928"/>
+          </a:xfrm>
+          <a:prstGeom prst="rect">
+            <a:avLst/>
+          </a:prstGeom>
+        </p:spPr>
+      </p:pic>
+      <p:graphicFrame>
+        <p:nvGraphicFramePr>
+          <p:cNvPr id="7" name="Chart 6"/>
+          <p:cNvGraphicFramePr>
+            <a:graphicFrameLocks noGrp="1"/>
+          </p:cNvGraphicFramePr>
+          <p:nvPr/>
+        </p:nvGraphicFramePr>
+        <p:xfrm>
+          <a:off x="411480" y="1783080"/>
+          <a:ext cx="6355080" cy="4526280"/>
+        </p:xfrm>
+        <a:graphic>
+          <a:graphicData uri="http://schemas.openxmlformats.org/drawingml/2006/chart">
+            <c:chart xmlns:c="http://schemas.openxmlformats.org/drawingml/2006/chart" r:id="rId3"/>
+          </a:graphicData>
+        </a:graphic>
+      </p:graphicFrame>
+      <p:sp>
+        <p:nvSpPr>
+          <p:cNvPr id="8" name="TextBox 7"/>
+          <p:cNvSpPr txBox="1"/>
+          <p:nvPr/>
+        </p:nvSpPr>
+        <p:spPr>
+          <a:xfrm>
+            <a:off x="502920" y="1325880"/>
+            <a:ext cx="6217920" cy="365760"/>
+          </a:xfrm>
+          <a:prstGeom prst="rect">
+            <a:avLst/>
+          </a:prstGeom>
+          <a:noFill/>
+        </p:spPr>
+        <p:txBody>
+          <a:bodyPr wrap="square" anchor="t" lIns="0" rIns="0" tIns="0" bIns="0">
+            <a:spAutoFit/>
+          </a:bodyPr>
+          <a:lstStyle/>
+          <a:p>
+            <a:pPr algn="l"/>
+            <a:r>
+              <a:rPr sz="1800" b="1">
+                <a:solidFill>
+                  <a:srgbClr val="2B164F"/>
+                </a:solidFill>
+                <a:latin typeface="Century Gothic"/>
+              </a:rPr>
+              <a:t>Por programa</a:t>
+            </a:r>
+          </a:p>
+        </p:txBody>
+      </p:sp>
+      <p:sp>
+        <p:nvSpPr>
+          <p:cNvPr id="9" name="TextBox 8"/>
+          <p:cNvSpPr txBox="1"/>
+          <p:nvPr/>
+        </p:nvSpPr>
+        <p:spPr>
+          <a:xfrm>
+            <a:off x="7086600" y="1325880"/>
+            <a:ext cx="4572000" cy="365760"/>
+          </a:xfrm>
+          <a:prstGeom prst="rect">
+            <a:avLst/>
+          </a:prstGeom>
+          <a:noFill/>
+        </p:spPr>
+        <p:txBody>
+          <a:bodyPr wrap="square" anchor="t" lIns="0" rIns="0" tIns="0" bIns="0">
+            <a:spAutoFit/>
+          </a:bodyPr>
+          <a:lstStyle/>
+          <a:p>
+            <a:pPr algn="l"/>
+            <a:r>
+              <a:rPr sz="1800" b="1">
+                <a:solidFill>
+                  <a:srgbClr val="2B164F"/>
+                </a:solidFill>
+                <a:latin typeface="Century Gothic"/>
+              </a:rPr>
+              <a:t>Por provincia</a:t>
+            </a:r>
+          </a:p>
+        </p:txBody>
+      </p:sp>
+      <p:sp>
+        <p:nvSpPr>
+          <p:cNvPr id="10" name="TextBox 9"/>
+          <p:cNvSpPr txBox="1"/>
+          <p:nvPr/>
+        </p:nvSpPr>
+        <p:spPr>
+          <a:xfrm>
+            <a:off x="7086600" y="1828800"/>
+            <a:ext cx="3108960" cy="274320"/>
+          </a:xfrm>
+          <a:prstGeom prst="rect">
+            <a:avLst/>
+          </a:prstGeom>
+          <a:noFill/>
+        </p:spPr>
+        <p:txBody>
+          <a:bodyPr wrap="square" anchor="t" lIns="0" rIns="0" tIns="0" bIns="0">
+            <a:spAutoFit/>
+          </a:bodyPr>
+          <a:lstStyle/>
+          <a:p>
+            <a:pPr algn="l"/>
+            <a:r>
+              <a:rPr sz="1350" b="0">
+                <a:solidFill>
+                  <a:srgbClr val="20202B"/>
+                </a:solidFill>
+                <a:latin typeface="Calibri"/>
+              </a:rPr>
+              <a:t>Guayas</a:t>
+            </a:r>
+          </a:p>
+        </p:txBody>
+      </p:sp>
+      <p:sp>
+        <p:nvSpPr>
+          <p:cNvPr id="11" name="TextBox 10"/>
+          <p:cNvSpPr txBox="1"/>
+          <p:nvPr/>
+        </p:nvSpPr>
+        <p:spPr>
+          <a:xfrm>
+            <a:off x="9829800" y="1828800"/>
+            <a:ext cx="1828800" cy="274320"/>
+          </a:xfrm>
+          <a:prstGeom prst="rect">
+            <a:avLst/>
+          </a:prstGeom>
+          <a:noFill/>
+        </p:spPr>
+        <p:txBody>
+          <a:bodyPr wrap="square" anchor="t" lIns="0" rIns="0" tIns="0" bIns="0">
+            <a:spAutoFit/>
+          </a:bodyPr>
+          <a:lstStyle/>
+          <a:p>
+            <a:pPr algn="r"/>
+            <a:r>
+              <a:rPr sz="1350" b="1">
+                <a:solidFill>
+                  <a:srgbClr val="20202B"/>
+                </a:solidFill>
+                <a:latin typeface="Calibri"/>
+              </a:rPr>
+              <a:t>71,0 %</a:t>
+            </a:r>
+          </a:p>
+        </p:txBody>
+      </p:sp>
+      <p:sp>
+        <p:nvSpPr>
+          <p:cNvPr id="12" name="Rounded Rectangle 11"/>
+          <p:cNvSpPr/>
+          <p:nvPr/>
+        </p:nvSpPr>
+        <p:spPr>
+          <a:xfrm>
+            <a:off x="7086600" y="2130552"/>
+            <a:ext cx="4572000" cy="82296"/>
+          </a:xfrm>
+          <a:prstGeom prst="roundRect">
+            <a:avLst>
+              <a:gd name="adj" fmla="val 50000"/>
+            </a:avLst>
+          </a:prstGeom>
+          <a:solidFill>
+            <a:srgbClr val="EFECF5"/>
+          </a:solidFill>
+          <a:ln>
+            <a:noFill/>
+          </a:ln>
+          <a:effectLst/>
+        </p:spPr>
+        <p:txBody>
+          <a:bodyPr rtlCol="0" anchor="ctr"/>
+          <a:lstStyle/>
+          <a:p>
+            <a:pPr algn="ctr"/>
+          </a:p>
+        </p:txBody>
+      </p:sp>
+      <p:sp>
+        <p:nvSpPr>
+          <p:cNvPr id="13" name="Rounded Rectangle 12"/>
+          <p:cNvSpPr/>
+          <p:nvPr/>
+        </p:nvSpPr>
+        <p:spPr>
+          <a:xfrm>
+            <a:off x="7086600" y="2130552"/>
+            <a:ext cx="3246270" cy="82296"/>
+          </a:xfrm>
+          <a:prstGeom prst="roundRect">
+            <a:avLst>
+              <a:gd name="adj" fmla="val 50000"/>
+            </a:avLst>
+          </a:prstGeom>
+          <a:solidFill>
+            <a:srgbClr val="5A369A"/>
+          </a:solidFill>
+          <a:ln>
+            <a:noFill/>
+          </a:ln>
+          <a:effectLst/>
+        </p:spPr>
+        <p:txBody>
+          <a:bodyPr rtlCol="0" anchor="ctr"/>
+          <a:lstStyle/>
+          <a:p>
+            <a:pPr algn="ctr"/>
+          </a:p>
+        </p:txBody>
+      </p:sp>
+      <p:sp>
+        <p:nvSpPr>
+          <p:cNvPr id="14" name="TextBox 13"/>
+          <p:cNvSpPr txBox="1"/>
+          <p:nvPr/>
+        </p:nvSpPr>
+        <p:spPr>
+          <a:xfrm>
+            <a:off x="7086600" y="2286000"/>
+            <a:ext cx="3108960" cy="274320"/>
+          </a:xfrm>
+          <a:prstGeom prst="rect">
+            <a:avLst/>
+          </a:prstGeom>
+          <a:noFill/>
+        </p:spPr>
+        <p:txBody>
+          <a:bodyPr wrap="square" anchor="t" lIns="0" rIns="0" tIns="0" bIns="0">
+            <a:spAutoFit/>
+          </a:bodyPr>
+          <a:lstStyle/>
+          <a:p>
+            <a:pPr algn="l"/>
+            <a:r>
+              <a:rPr sz="1350" b="0">
+                <a:solidFill>
+                  <a:srgbClr val="20202B"/>
+                </a:solidFill>
+                <a:latin typeface="Calibri"/>
+              </a:rPr>
+              <a:t>Manabí</a:t>
+            </a:r>
+          </a:p>
+        </p:txBody>
+      </p:sp>
+      <p:sp>
+        <p:nvSpPr>
+          <p:cNvPr id="15" name="TextBox 14"/>
+          <p:cNvSpPr txBox="1"/>
+          <p:nvPr/>
+        </p:nvSpPr>
+        <p:spPr>
+          <a:xfrm>
+            <a:off x="9829800" y="2286000"/>
+            <a:ext cx="1828800" cy="274320"/>
+          </a:xfrm>
+          <a:prstGeom prst="rect">
+            <a:avLst/>
+          </a:prstGeom>
+          <a:noFill/>
+        </p:spPr>
+        <p:txBody>
+          <a:bodyPr wrap="square" anchor="t" lIns="0" rIns="0" tIns="0" bIns="0">
+            <a:spAutoFit/>
+          </a:bodyPr>
+          <a:lstStyle/>
+          <a:p>
+            <a:pPr algn="r"/>
+            <a:r>
+              <a:rPr sz="1350" b="1">
+                <a:solidFill>
+                  <a:srgbClr val="20202B"/>
+                </a:solidFill>
+                <a:latin typeface="Calibri"/>
+              </a:rPr>
+              <a:t>71,1 %</a:t>
+            </a:r>
+          </a:p>
+        </p:txBody>
+      </p:sp>
+      <p:sp>
+        <p:nvSpPr>
+          <p:cNvPr id="16" name="Rounded Rectangle 15"/>
+          <p:cNvSpPr/>
+          <p:nvPr/>
+        </p:nvSpPr>
+        <p:spPr>
+          <a:xfrm>
+            <a:off x="7086600" y="2587752"/>
+            <a:ext cx="4572000" cy="82296"/>
+          </a:xfrm>
+          <a:prstGeom prst="roundRect">
+            <a:avLst>
+              <a:gd name="adj" fmla="val 50000"/>
+            </a:avLst>
+          </a:prstGeom>
+          <a:solidFill>
+            <a:srgbClr val="EFECF5"/>
+          </a:solidFill>
+          <a:ln>
+            <a:noFill/>
+          </a:ln>
+          <a:effectLst/>
+        </p:spPr>
+        <p:txBody>
+          <a:bodyPr rtlCol="0" anchor="ctr"/>
+          <a:lstStyle/>
+          <a:p>
+            <a:pPr algn="ctr"/>
+          </a:p>
+        </p:txBody>
+      </p:sp>
+      <p:sp>
+        <p:nvSpPr>
+          <p:cNvPr id="17" name="Rounded Rectangle 16"/>
+          <p:cNvSpPr/>
+          <p:nvPr/>
+        </p:nvSpPr>
+        <p:spPr>
+          <a:xfrm>
+            <a:off x="7086600" y="2587752"/>
+            <a:ext cx="3251322" cy="82296"/>
+          </a:xfrm>
+          <a:prstGeom prst="roundRect">
+            <a:avLst>
+              <a:gd name="adj" fmla="val 50000"/>
+            </a:avLst>
+          </a:prstGeom>
+          <a:solidFill>
+            <a:srgbClr val="5A369A"/>
+          </a:solidFill>
+          <a:ln>
+            <a:noFill/>
+          </a:ln>
+          <a:effectLst/>
+        </p:spPr>
+        <p:txBody>
+          <a:bodyPr rtlCol="0" anchor="ctr"/>
+          <a:lstStyle/>
+          <a:p>
+            <a:pPr algn="ctr"/>
+          </a:p>
+        </p:txBody>
+      </p:sp>
+      <p:sp>
+        <p:nvSpPr>
+          <p:cNvPr id="18" name="TextBox 17"/>
+          <p:cNvSpPr txBox="1"/>
+          <p:nvPr/>
+        </p:nvSpPr>
+        <p:spPr>
+          <a:xfrm>
+            <a:off x="7086600" y="2743200"/>
+            <a:ext cx="3108960" cy="274320"/>
+          </a:xfrm>
+          <a:prstGeom prst="rect">
+            <a:avLst/>
+          </a:prstGeom>
+          <a:noFill/>
+        </p:spPr>
+        <p:txBody>
+          <a:bodyPr wrap="square" anchor="t" lIns="0" rIns="0" tIns="0" bIns="0">
+            <a:spAutoFit/>
+          </a:bodyPr>
+          <a:lstStyle/>
+          <a:p>
+            <a:pPr algn="l"/>
+            <a:r>
+              <a:rPr sz="1350" b="0">
+                <a:solidFill>
+                  <a:srgbClr val="20202B"/>
+                </a:solidFill>
+                <a:latin typeface="Calibri"/>
+              </a:rPr>
+              <a:t>Los Ríos</a:t>
+            </a:r>
+          </a:p>
+        </p:txBody>
+      </p:sp>
+      <p:sp>
+        <p:nvSpPr>
+          <p:cNvPr id="19" name="TextBox 18"/>
+          <p:cNvSpPr txBox="1"/>
+          <p:nvPr/>
+        </p:nvSpPr>
+        <p:spPr>
+          <a:xfrm>
+            <a:off x="9829800" y="2743200"/>
+            <a:ext cx="1828800" cy="274320"/>
+          </a:xfrm>
+          <a:prstGeom prst="rect">
+            <a:avLst/>
+          </a:prstGeom>
+          <a:noFill/>
+        </p:spPr>
+        <p:txBody>
+          <a:bodyPr wrap="square" anchor="t" lIns="0" rIns="0" tIns="0" bIns="0">
+            <a:spAutoFit/>
+          </a:bodyPr>
+          <a:lstStyle/>
+          <a:p>
+            <a:pPr algn="r"/>
+            <a:r>
+              <a:rPr sz="1350" b="1">
+                <a:solidFill>
+                  <a:srgbClr val="20202B"/>
+                </a:solidFill>
+                <a:latin typeface="Calibri"/>
+              </a:rPr>
+              <a:t>71,0 %</a:t>
+            </a:r>
+          </a:p>
+        </p:txBody>
+      </p:sp>
+      <p:sp>
+        <p:nvSpPr>
+          <p:cNvPr id="20" name="Rounded Rectangle 19"/>
+          <p:cNvSpPr/>
+          <p:nvPr/>
+        </p:nvSpPr>
+        <p:spPr>
+          <a:xfrm>
+            <a:off x="7086600" y="3044952"/>
+            <a:ext cx="4572000" cy="82296"/>
+          </a:xfrm>
+          <a:prstGeom prst="roundRect">
+            <a:avLst>
+              <a:gd name="adj" fmla="val 50000"/>
+            </a:avLst>
+          </a:prstGeom>
+          <a:solidFill>
+            <a:srgbClr val="EFECF5"/>
+          </a:solidFill>
+          <a:ln>
+            <a:noFill/>
+          </a:ln>
+          <a:effectLst/>
+        </p:spPr>
+        <p:txBody>
+          <a:bodyPr rtlCol="0" anchor="ctr"/>
+          <a:lstStyle/>
+          <a:p>
+            <a:pPr algn="ctr"/>
+          </a:p>
+        </p:txBody>
+      </p:sp>
+      <p:sp>
+        <p:nvSpPr>
+          <p:cNvPr id="21" name="Rounded Rectangle 20"/>
+          <p:cNvSpPr/>
+          <p:nvPr/>
+        </p:nvSpPr>
+        <p:spPr>
+          <a:xfrm>
+            <a:off x="7086600" y="3044952"/>
+            <a:ext cx="3247834" cy="82296"/>
+          </a:xfrm>
+          <a:prstGeom prst="roundRect">
+            <a:avLst>
+              <a:gd name="adj" fmla="val 50000"/>
+            </a:avLst>
+          </a:prstGeom>
+          <a:solidFill>
+            <a:srgbClr val="5A369A"/>
+          </a:solidFill>
+          <a:ln>
+            <a:noFill/>
+          </a:ln>
+          <a:effectLst/>
+        </p:spPr>
+        <p:txBody>
+          <a:bodyPr rtlCol="0" anchor="ctr"/>
+          <a:lstStyle/>
+          <a:p>
+            <a:pPr algn="ctr"/>
+          </a:p>
+        </p:txBody>
+      </p:sp>
+      <p:sp>
+        <p:nvSpPr>
+          <p:cNvPr id="22" name="TextBox 21"/>
+          <p:cNvSpPr txBox="1"/>
+          <p:nvPr/>
+        </p:nvSpPr>
+        <p:spPr>
+          <a:xfrm>
+            <a:off x="7086600" y="3200400"/>
+            <a:ext cx="3108960" cy="274320"/>
+          </a:xfrm>
+          <a:prstGeom prst="rect">
+            <a:avLst/>
+          </a:prstGeom>
+          <a:noFill/>
+        </p:spPr>
+        <p:txBody>
+          <a:bodyPr wrap="square" anchor="t" lIns="0" rIns="0" tIns="0" bIns="0">
+            <a:spAutoFit/>
+          </a:bodyPr>
+          <a:lstStyle/>
+          <a:p>
+            <a:pPr algn="l"/>
+            <a:r>
+              <a:rPr sz="1350" b="0">
+                <a:solidFill>
+                  <a:srgbClr val="20202B"/>
+                </a:solidFill>
+                <a:latin typeface="Calibri"/>
+              </a:rPr>
+              <a:t>Pichincha</a:t>
+            </a:r>
+          </a:p>
+        </p:txBody>
+      </p:sp>
+      <p:sp>
+        <p:nvSpPr>
+          <p:cNvPr id="23" name="TextBox 22"/>
+          <p:cNvSpPr txBox="1"/>
+          <p:nvPr/>
+        </p:nvSpPr>
+        <p:spPr>
+          <a:xfrm>
+            <a:off x="9829800" y="3200400"/>
+            <a:ext cx="1828800" cy="274320"/>
+          </a:xfrm>
+          <a:prstGeom prst="rect">
+            <a:avLst/>
+          </a:prstGeom>
+          <a:noFill/>
+        </p:spPr>
+        <p:txBody>
+          <a:bodyPr wrap="square" anchor="t" lIns="0" rIns="0" tIns="0" bIns="0">
+            <a:spAutoFit/>
+          </a:bodyPr>
+          <a:lstStyle/>
+          <a:p>
+            <a:pPr algn="r"/>
+            <a:r>
+              <a:rPr sz="1350" b="1">
+                <a:solidFill>
+                  <a:srgbClr val="20202B"/>
+                </a:solidFill>
+                <a:latin typeface="Calibri"/>
+              </a:rPr>
+              <a:t>71,2 %</a:t>
+            </a:r>
+          </a:p>
+        </p:txBody>
+      </p:sp>
+      <p:sp>
+        <p:nvSpPr>
+          <p:cNvPr id="24" name="Rounded Rectangle 23"/>
+          <p:cNvSpPr/>
+          <p:nvPr/>
+        </p:nvSpPr>
+        <p:spPr>
+          <a:xfrm>
+            <a:off x="7086600" y="3502152"/>
+            <a:ext cx="4572000" cy="82296"/>
+          </a:xfrm>
+          <a:prstGeom prst="roundRect">
+            <a:avLst>
+              <a:gd name="adj" fmla="val 50000"/>
+            </a:avLst>
+          </a:prstGeom>
+          <a:solidFill>
+            <a:srgbClr val="EFECF5"/>
+          </a:solidFill>
+          <a:ln>
+            <a:noFill/>
+          </a:ln>
+          <a:effectLst/>
+        </p:spPr>
+        <p:txBody>
+          <a:bodyPr rtlCol="0" anchor="ctr"/>
+          <a:lstStyle/>
+          <a:p>
+            <a:pPr algn="ctr"/>
+          </a:p>
+        </p:txBody>
+      </p:sp>
+      <p:sp>
+        <p:nvSpPr>
+          <p:cNvPr id="25" name="Rounded Rectangle 24"/>
+          <p:cNvSpPr/>
+          <p:nvPr/>
+        </p:nvSpPr>
+        <p:spPr>
+          <a:xfrm>
+            <a:off x="7086600" y="3502152"/>
+            <a:ext cx="3256482" cy="82296"/>
+          </a:xfrm>
+          <a:prstGeom prst="roundRect">
+            <a:avLst>
+              <a:gd name="adj" fmla="val 50000"/>
+            </a:avLst>
+          </a:prstGeom>
+          <a:solidFill>
+            <a:srgbClr val="5A369A"/>
+          </a:solidFill>
+          <a:ln>
+            <a:noFill/>
+          </a:ln>
+          <a:effectLst/>
+        </p:spPr>
+        <p:txBody>
+          <a:bodyPr rtlCol="0" anchor="ctr"/>
+          <a:lstStyle/>
+          <a:p>
+            <a:pPr algn="ctr"/>
+          </a:p>
+        </p:txBody>
+      </p:sp>
+      <p:sp>
+        <p:nvSpPr>
+          <p:cNvPr id="26" name="TextBox 25"/>
+          <p:cNvSpPr txBox="1"/>
+          <p:nvPr/>
+        </p:nvSpPr>
+        <p:spPr>
+          <a:xfrm>
+            <a:off x="7086600" y="3657600"/>
+            <a:ext cx="3108960" cy="274320"/>
+          </a:xfrm>
+          <a:prstGeom prst="rect">
+            <a:avLst/>
+          </a:prstGeom>
+          <a:noFill/>
+        </p:spPr>
+        <p:txBody>
+          <a:bodyPr wrap="square" anchor="t" lIns="0" rIns="0" tIns="0" bIns="0">
+            <a:spAutoFit/>
+          </a:bodyPr>
+          <a:lstStyle/>
+          <a:p>
+            <a:pPr algn="l"/>
+            <a:r>
+              <a:rPr sz="1350" b="0">
+                <a:solidFill>
+                  <a:srgbClr val="20202B"/>
+                </a:solidFill>
+                <a:latin typeface="Calibri"/>
+              </a:rPr>
+              <a:t>Esmeraldas</a:t>
+            </a:r>
+          </a:p>
+        </p:txBody>
+      </p:sp>
+      <p:sp>
+        <p:nvSpPr>
+          <p:cNvPr id="27" name="TextBox 26"/>
+          <p:cNvSpPr txBox="1"/>
+          <p:nvPr/>
+        </p:nvSpPr>
+        <p:spPr>
+          <a:xfrm>
+            <a:off x="9829800" y="3657600"/>
+            <a:ext cx="1828800" cy="274320"/>
+          </a:xfrm>
+          <a:prstGeom prst="rect">
+            <a:avLst/>
+          </a:prstGeom>
+          <a:noFill/>
+        </p:spPr>
+        <p:txBody>
+          <a:bodyPr wrap="square" anchor="t" lIns="0" rIns="0" tIns="0" bIns="0">
+            <a:spAutoFit/>
+          </a:bodyPr>
+          <a:lstStyle/>
+          <a:p>
+            <a:pPr algn="r"/>
+            <a:r>
+              <a:rPr sz="1350" b="1">
+                <a:solidFill>
+                  <a:srgbClr val="20202B"/>
+                </a:solidFill>
+                <a:latin typeface="Calibri"/>
+              </a:rPr>
+              <a:t>70,2 %</a:t>
+            </a:r>
+          </a:p>
+        </p:txBody>
+      </p:sp>
+      <p:sp>
+        <p:nvSpPr>
+          <p:cNvPr id="28" name="Rounded Rectangle 27"/>
+          <p:cNvSpPr/>
+          <p:nvPr/>
+        </p:nvSpPr>
+        <p:spPr>
+          <a:xfrm>
+            <a:off x="7086600" y="3959352"/>
+            <a:ext cx="4572000" cy="82296"/>
+          </a:xfrm>
+          <a:prstGeom prst="roundRect">
+            <a:avLst>
+              <a:gd name="adj" fmla="val 50000"/>
+            </a:avLst>
+          </a:prstGeom>
+          <a:solidFill>
+            <a:srgbClr val="EFECF5"/>
+          </a:solidFill>
+          <a:ln>
+            <a:noFill/>
+          </a:ln>
+          <a:effectLst/>
+        </p:spPr>
+        <p:txBody>
+          <a:bodyPr rtlCol="0" anchor="ctr"/>
+          <a:lstStyle/>
+          <a:p>
+            <a:pPr algn="ctr"/>
+          </a:p>
+        </p:txBody>
+      </p:sp>
+      <p:sp>
+        <p:nvSpPr>
+          <p:cNvPr id="29" name="Rounded Rectangle 28"/>
+          <p:cNvSpPr/>
+          <p:nvPr/>
+        </p:nvSpPr>
+        <p:spPr>
+          <a:xfrm>
+            <a:off x="7086600" y="3959352"/>
+            <a:ext cx="3210472" cy="82296"/>
+          </a:xfrm>
+          <a:prstGeom prst="roundRect">
+            <a:avLst>
+              <a:gd name="adj" fmla="val 50000"/>
+            </a:avLst>
+          </a:prstGeom>
+          <a:solidFill>
+            <a:srgbClr val="5A369A"/>
+          </a:solidFill>
+          <a:ln>
+            <a:noFill/>
+          </a:ln>
+          <a:effectLst/>
+        </p:spPr>
+        <p:txBody>
+          <a:bodyPr rtlCol="0" anchor="ctr"/>
+          <a:lstStyle/>
+          <a:p>
+            <a:pPr algn="ctr"/>
+          </a:p>
+        </p:txBody>
+      </p:sp>
+      <p:sp>
+        <p:nvSpPr>
+          <p:cNvPr id="30" name="TextBox 29"/>
+          <p:cNvSpPr txBox="1"/>
+          <p:nvPr/>
+        </p:nvSpPr>
+        <p:spPr>
+          <a:xfrm>
+            <a:off x="7086600" y="4114800"/>
+            <a:ext cx="3108960" cy="274320"/>
+          </a:xfrm>
+          <a:prstGeom prst="rect">
+            <a:avLst/>
+          </a:prstGeom>
+          <a:noFill/>
+        </p:spPr>
+        <p:txBody>
+          <a:bodyPr wrap="square" anchor="t" lIns="0" rIns="0" tIns="0" bIns="0">
+            <a:spAutoFit/>
+          </a:bodyPr>
+          <a:lstStyle/>
+          <a:p>
+            <a:pPr algn="l"/>
+            <a:r>
+              <a:rPr sz="1350" b="0">
+                <a:solidFill>
+                  <a:srgbClr val="20202B"/>
+                </a:solidFill>
+                <a:latin typeface="Calibri"/>
+              </a:rPr>
+              <a:t>Chimborazo</a:t>
+            </a:r>
+          </a:p>
+        </p:txBody>
+      </p:sp>
+      <p:sp>
+        <p:nvSpPr>
+          <p:cNvPr id="31" name="TextBox 30"/>
+          <p:cNvSpPr txBox="1"/>
+          <p:nvPr/>
+        </p:nvSpPr>
+        <p:spPr>
+          <a:xfrm>
+            <a:off x="9829800" y="4114800"/>
+            <a:ext cx="1828800" cy="274320"/>
+          </a:xfrm>
+          <a:prstGeom prst="rect">
+            <a:avLst/>
+          </a:prstGeom>
+          <a:noFill/>
+        </p:spPr>
+        <p:txBody>
+          <a:bodyPr wrap="square" anchor="t" lIns="0" rIns="0" tIns="0" bIns="0">
+            <a:spAutoFit/>
+          </a:bodyPr>
+          <a:lstStyle/>
+          <a:p>
+            <a:pPr algn="r"/>
+            <a:r>
+              <a:rPr sz="1350" b="1">
+                <a:solidFill>
+                  <a:srgbClr val="20202B"/>
+                </a:solidFill>
+                <a:latin typeface="Calibri"/>
+              </a:rPr>
+              <a:t>71,2 %</a:t>
+            </a:r>
+          </a:p>
+        </p:txBody>
+      </p:sp>
+      <p:sp>
+        <p:nvSpPr>
+          <p:cNvPr id="32" name="Rounded Rectangle 31"/>
+          <p:cNvSpPr/>
+          <p:nvPr/>
+        </p:nvSpPr>
+        <p:spPr>
+          <a:xfrm>
+            <a:off x="7086600" y="4416552"/>
+            <a:ext cx="4572000" cy="82296"/>
+          </a:xfrm>
+          <a:prstGeom prst="roundRect">
+            <a:avLst>
+              <a:gd name="adj" fmla="val 50000"/>
+            </a:avLst>
+          </a:prstGeom>
+          <a:solidFill>
+            <a:srgbClr val="EFECF5"/>
+          </a:solidFill>
+          <a:ln>
+            <a:noFill/>
+          </a:ln>
+          <a:effectLst/>
+        </p:spPr>
+        <p:txBody>
+          <a:bodyPr rtlCol="0" anchor="ctr"/>
+          <a:lstStyle/>
+          <a:p>
+            <a:pPr algn="ctr"/>
+          </a:p>
+        </p:txBody>
+      </p:sp>
+      <p:sp>
+        <p:nvSpPr>
+          <p:cNvPr id="33" name="Rounded Rectangle 32"/>
+          <p:cNvSpPr/>
+          <p:nvPr/>
+        </p:nvSpPr>
+        <p:spPr>
+          <a:xfrm>
+            <a:off x="7086600" y="4416552"/>
+            <a:ext cx="3255313" cy="82296"/>
+          </a:xfrm>
+          <a:prstGeom prst="roundRect">
+            <a:avLst>
+              <a:gd name="adj" fmla="val 50000"/>
+            </a:avLst>
+          </a:prstGeom>
+          <a:solidFill>
+            <a:srgbClr val="5A369A"/>
+          </a:solidFill>
+          <a:ln>
+            <a:noFill/>
+          </a:ln>
+          <a:effectLst/>
+        </p:spPr>
+        <p:txBody>
+          <a:bodyPr rtlCol="0" anchor="ctr"/>
+          <a:lstStyle/>
+          <a:p>
+            <a:pPr algn="ctr"/>
+          </a:p>
+        </p:txBody>
+      </p:sp>
+      <p:sp>
+        <p:nvSpPr>
+          <p:cNvPr id="34" name="TextBox 33"/>
+          <p:cNvSpPr txBox="1"/>
+          <p:nvPr/>
+        </p:nvSpPr>
+        <p:spPr>
+          <a:xfrm>
+            <a:off x="7086600" y="4572000"/>
+            <a:ext cx="3108960" cy="274320"/>
+          </a:xfrm>
+          <a:prstGeom prst="rect">
+            <a:avLst/>
+          </a:prstGeom>
+          <a:noFill/>
+        </p:spPr>
+        <p:txBody>
+          <a:bodyPr wrap="square" anchor="t" lIns="0" rIns="0" tIns="0" bIns="0">
+            <a:spAutoFit/>
+          </a:bodyPr>
+          <a:lstStyle/>
+          <a:p>
+            <a:pPr algn="l"/>
+            <a:r>
+              <a:rPr sz="1350" b="0">
+                <a:solidFill>
+                  <a:srgbClr val="20202B"/>
+                </a:solidFill>
+                <a:latin typeface="Calibri"/>
+              </a:rPr>
+              <a:t>Cotopaxi</a:t>
+            </a:r>
+          </a:p>
+        </p:txBody>
+      </p:sp>
+      <p:sp>
+        <p:nvSpPr>
+          <p:cNvPr id="35" name="TextBox 34"/>
+          <p:cNvSpPr txBox="1"/>
+          <p:nvPr/>
+        </p:nvSpPr>
+        <p:spPr>
+          <a:xfrm>
+            <a:off x="9829800" y="4572000"/>
+            <a:ext cx="1828800" cy="274320"/>
+          </a:xfrm>
+          <a:prstGeom prst="rect">
+            <a:avLst/>
+          </a:prstGeom>
+          <a:noFill/>
+        </p:spPr>
+        <p:txBody>
+          <a:bodyPr wrap="square" anchor="t" lIns="0" rIns="0" tIns="0" bIns="0">
+            <a:spAutoFit/>
+          </a:bodyPr>
+          <a:lstStyle/>
+          <a:p>
+            <a:pPr algn="r"/>
+            <a:r>
+              <a:rPr sz="1350" b="1">
+                <a:solidFill>
+                  <a:srgbClr val="20202B"/>
+                </a:solidFill>
+                <a:latin typeface="Calibri"/>
+              </a:rPr>
+              <a:t>71,2 %</a:t>
+            </a:r>
+          </a:p>
+        </p:txBody>
+      </p:sp>
+      <p:sp>
+        <p:nvSpPr>
+          <p:cNvPr id="36" name="Rounded Rectangle 35"/>
+          <p:cNvSpPr/>
+          <p:nvPr/>
+        </p:nvSpPr>
+        <p:spPr>
+          <a:xfrm>
+            <a:off x="7086600" y="4873752"/>
+            <a:ext cx="4572000" cy="82296"/>
+          </a:xfrm>
+          <a:prstGeom prst="roundRect">
+            <a:avLst>
+              <a:gd name="adj" fmla="val 50000"/>
+            </a:avLst>
+          </a:prstGeom>
+          <a:solidFill>
+            <a:srgbClr val="EFECF5"/>
+          </a:solidFill>
+          <a:ln>
+            <a:noFill/>
+          </a:ln>
+          <a:effectLst/>
+        </p:spPr>
+        <p:txBody>
+          <a:bodyPr rtlCol="0" anchor="ctr"/>
+          <a:lstStyle/>
+          <a:p>
+            <a:pPr algn="ctr"/>
+          </a:p>
+        </p:txBody>
+      </p:sp>
+      <p:sp>
+        <p:nvSpPr>
+          <p:cNvPr id="37" name="Rounded Rectangle 36"/>
+          <p:cNvSpPr/>
+          <p:nvPr/>
+        </p:nvSpPr>
+        <p:spPr>
+          <a:xfrm>
+            <a:off x="7086600" y="4873752"/>
+            <a:ext cx="3253257" cy="82296"/>
+          </a:xfrm>
+          <a:prstGeom prst="roundRect">
+            <a:avLst>
+              <a:gd name="adj" fmla="val 50000"/>
+            </a:avLst>
+          </a:prstGeom>
+          <a:solidFill>
+            <a:srgbClr val="5A369A"/>
+          </a:solidFill>
+          <a:ln>
+            <a:noFill/>
+          </a:ln>
+          <a:effectLst/>
+        </p:spPr>
+        <p:txBody>
+          <a:bodyPr rtlCol="0" anchor="ctr"/>
+          <a:lstStyle/>
+          <a:p>
+            <a:pPr algn="ctr"/>
+          </a:p>
+        </p:txBody>
+      </p:sp>
+      <p:sp>
+        <p:nvSpPr>
+          <p:cNvPr id="38" name="Rounded Rectangle 37"/>
+          <p:cNvSpPr/>
+          <p:nvPr/>
+        </p:nvSpPr>
+        <p:spPr>
+          <a:xfrm>
+            <a:off x="7086600" y="5257800"/>
+            <a:ext cx="4572000" cy="1005840"/>
+          </a:xfrm>
+          <a:prstGeom prst="roundRect">
+            <a:avLst>
+              <a:gd name="adj" fmla="val 12000"/>
+            </a:avLst>
+          </a:prstGeom>
+          <a:solidFill>
+            <a:srgbClr val="F1EDFA"/>
+          </a:solidFill>
+          <a:ln>
+            <a:noFill/>
+          </a:ln>
+          <a:effectLst/>
+        </p:spPr>
+        <p:txBody>
+          <a:bodyPr rtlCol="0" anchor="ctr"/>
+          <a:lstStyle/>
+          <a:p>
+            <a:pPr algn="ctr"/>
+          </a:p>
+        </p:txBody>
+      </p:sp>
+      <p:sp>
+        <p:nvSpPr>
+          <p:cNvPr id="39" name="Oval 38"/>
+          <p:cNvSpPr/>
+          <p:nvPr/>
+        </p:nvSpPr>
+        <p:spPr>
+          <a:xfrm>
+            <a:off x="7269480" y="5486400"/>
+            <a:ext cx="548640" cy="548640"/>
+          </a:xfrm>
+          <a:prstGeom prst="ellipse">
+            <a:avLst/>
+          </a:prstGeom>
+          <a:solidFill>
+            <a:srgbClr val="512F8D"/>
+          </a:solidFill>
+          <a:ln>
+            <a:noFill/>
+          </a:ln>
+          <a:effectLst/>
+        </p:spPr>
+        <p:txBody>
+          <a:bodyPr rtlCol="0" anchor="ctr"/>
+          <a:lstStyle/>
+          <a:p>
+            <a:pPr algn="ctr"/>
+          </a:p>
+        </p:txBody>
+      </p:sp>
+      <p:pic>
+        <p:nvPicPr>
+          <p:cNvPr id="40" name="Picture 39" descr="trending-up-blanco.png"/>
+          <p:cNvPicPr>
+            <a:picLocks noChangeAspect="1"/>
+          </p:cNvPicPr>
+          <p:nvPr/>
+        </p:nvPicPr>
+        <p:blipFill>
+          <a:blip r:embed="rId4"/>
+          <a:stretch>
+            <a:fillRect/>
+          </a:stretch>
+        </p:blipFill>
+        <p:spPr>
+          <a:xfrm>
+            <a:off x="7392924" y="5609844"/>
+            <a:ext cx="301752" cy="301752"/>
+          </a:xfrm>
+          <a:prstGeom prst="rect">
+            <a:avLst/>
+          </a:prstGeom>
+        </p:spPr>
+      </p:pic>
+      <p:sp>
+        <p:nvSpPr>
+          <p:cNvPr id="41" name="TextBox 40"/>
+          <p:cNvSpPr txBox="1"/>
+          <p:nvPr/>
+        </p:nvSpPr>
+        <p:spPr>
+          <a:xfrm>
+            <a:off x="7955279" y="5367528"/>
+            <a:ext cx="3520440" cy="786384"/>
+          </a:xfrm>
+          <a:prstGeom prst="rect">
+            <a:avLst/>
+          </a:prstGeom>
+          <a:noFill/>
+        </p:spPr>
+        <p:txBody>
+          <a:bodyPr wrap="square" anchor="ctr" lIns="0" rIns="0" tIns="0" bIns="0">
+            <a:spAutoFit/>
+          </a:bodyPr>
+          <a:lstStyle/>
+          <a:p>
+            <a:pPr algn="l"/>
+            <a:r>
+              <a:rPr sz="1250" b="0">
+                <a:solidFill>
+                  <a:srgbClr val="20202B"/>
+                </a:solidFill>
+                <a:latin typeface="Calibri"/>
+              </a:rPr>
+              <a:t>El presupuesto ejecutado 2026 asciende a USD 1.011,2 millones, el 71,0 % del presupuesto codificado.</a:t>
+            </a:r>
+          </a:p>
+        </p:txBody>
+      </p:sp>
+      <p:sp>
+        <p:nvSpPr>
+          <p:cNvPr id="42" name="TextBox 41"/>
+          <p:cNvSpPr txBox="1"/>
+          <p:nvPr/>
+        </p:nvSpPr>
+        <p:spPr>
+          <a:xfrm>
+            <a:off x="502920" y="6473952"/>
+            <a:ext cx="9738359" cy="228600"/>
+          </a:xfrm>
+          <a:prstGeom prst="rect">
+            <a:avLst/>
+          </a:prstGeom>
+          <a:noFill/>
+        </p:spPr>
+        <p:txBody>
+          <a:bodyPr wrap="square" anchor="t" lIns="0" rIns="0" tIns="0" bIns="0">
+            <a:spAutoFit/>
+          </a:bodyPr>
+          <a:lstStyle/>
+          <a:p>
+            <a:pPr algn="l"/>
+            <a:r>
+              <a:rPr sz="950" b="0">
+                <a:solidFill>
+                  <a:srgbClr val="7A748B"/>
+                </a:solidFill>
+                <a:latin typeface="Calibri"/>
+              </a:rPr>
+              <a:t>Fuente: Ministerio de Trabajo y Desarrollo Humano · 23 de octubre de 2026</a:t>
+            </a:r>
+          </a:p>
+        </p:txBody>
+      </p:sp>
+      <p:sp>
+        <p:nvSpPr>
+          <p:cNvPr id="43" name="TextBox 42"/>
+          <p:cNvSpPr txBox="1"/>
+          <p:nvPr/>
+        </p:nvSpPr>
+        <p:spPr>
+          <a:xfrm>
+            <a:off x="10789920" y="6473952"/>
+            <a:ext cx="914400" cy="228600"/>
+          </a:xfrm>
+          <a:prstGeom prst="rect">
+            <a:avLst/>
+          </a:prstGeom>
+          <a:noFill/>
+        </p:spPr>
+        <p:txBody>
+          <a:bodyPr wrap="square" anchor="t" lIns="0" rIns="0" tIns="0" bIns="0">
+            <a:spAutoFit/>
+          </a:bodyPr>
+          <a:lstStyle/>
+          <a:p>
+            <a:pPr algn="r"/>
+            <a:r>
+              <a:rPr sz="950" b="0">
+                <a:solidFill>
+                  <a:srgbClr val="7A748B"/>
+                </a:solidFill>
+                <a:latin typeface="Calibri"/>
+              </a:rPr>
+              <a:t>5 / 6</a:t>
+            </a:r>
+          </a:p>
+        </p:txBody>
+      </p:sp>
+    </p:spTree>
+  </p:cSld>
+  <p:clrMapOvr>
+    <a:masterClrMapping/>
+  </p:clrMapOvr>
+</p:sld>
+</file>
+
+<file path=ppt/slides/slide6.xml><?xml version="1.0" encoding="utf-8"?>
+<p:sld xmlns:a="http://schemas.openxmlformats.org/drawingml/2006/main" xmlns:p="http://schemas.openxmlformats.org/presentationml/2006/main" xmlns:r="http://schemas.openxmlformats.org/officeDocument/2006/relationships">
+  <p:cSld>
+    <p:spTree>
+      <p:nvGrpSpPr>
+        <p:cNvPr id="1" name=""/>
+        <p:cNvGrpSpPr/>
+        <p:nvPr/>
+      </p:nvGrpSpPr>
+      <p:grpSpPr/>
+      <p:sp>
+        <p:nvSpPr>
+          <p:cNvPr id="2" name="Rectangle 1"/>
+          <p:cNvSpPr/>
+          <p:nvPr/>
+        </p:nvSpPr>
+        <p:spPr>
+          <a:xfrm>
+            <a:off x="0" y="0"/>
+            <a:ext cx="12191695" cy="1024128"/>
+          </a:xfrm>
+          <a:prstGeom prst="rect">
+            <a:avLst/>
+          </a:prstGeom>
+          <a:gradFill rotWithShape="1">
+            <a:gsLst>
+              <a:gs pos="0">
+                <a:srgbClr val="2B164F"/>
+              </a:gs>
+              <a:gs pos="100000">
+                <a:srgbClr val="512F8D"/>
+              </a:gs>
+            </a:gsLst>
+            <a:lin scaled="0" ang="0"/>
+          </a:gradFill>
+          <a:ln>
+            <a:noFill/>
+          </a:ln>
+          <a:effectLst/>
+        </p:spPr>
+        <p:txBody>
+          <a:bodyPr rtlCol="0" anchor="ctr"/>
+          <a:lstStyle/>
+          <a:p>
+            <a:pPr algn="ctr"/>
+          </a:p>
+        </p:txBody>
+      </p:sp>
+      <p:sp>
+        <p:nvSpPr>
+          <p:cNvPr id="3" name="Rectangle 2"/>
+          <p:cNvSpPr/>
+          <p:nvPr/>
+        </p:nvSpPr>
+        <p:spPr>
+          <a:xfrm>
+            <a:off x="0" y="1024128"/>
+            <a:ext cx="12191695" cy="54864"/>
+          </a:xfrm>
+          <a:prstGeom prst="rect">
+            <a:avLst/>
+          </a:prstGeom>
+          <a:solidFill>
+            <a:srgbClr val="F8C018"/>
+          </a:solidFill>
+          <a:ln>
+            <a:noFill/>
+          </a:ln>
+          <a:effectLst/>
+        </p:spPr>
+        <p:txBody>
+          <a:bodyPr rtlCol="0" anchor="ctr"/>
+          <a:lstStyle/>
+          <a:p>
+            <a:pPr algn="ctr"/>
+          </a:p>
+        </p:txBody>
+      </p:sp>
+      <p:sp>
+        <p:nvSpPr>
+          <p:cNvPr id="4" name="TextBox 3"/>
+          <p:cNvSpPr txBox="1"/>
+          <p:nvPr/>
+        </p:nvSpPr>
+        <p:spPr>
+          <a:xfrm>
+            <a:off x="502920" y="182880"/>
+            <a:ext cx="8595360" cy="502920"/>
+          </a:xfrm>
+          <a:prstGeom prst="rect">
+            <a:avLst/>
+          </a:prstGeom>
+          <a:noFill/>
+        </p:spPr>
+        <p:txBody>
+          <a:bodyPr wrap="square" anchor="t" lIns="0" rIns="0" tIns="0" bIns="0">
+            <a:spAutoFit/>
+          </a:bodyPr>
+          <a:lstStyle/>
+          <a:p>
+            <a:pPr algn="l"/>
+            <a:r>
+              <a:rPr sz="2600" b="1">
+                <a:solidFill>
+                  <a:srgbClr val="FFFFFF"/>
+                </a:solidFill>
+                <a:latin typeface="Century Gothic"/>
+              </a:rPr>
               <a:t>Resultados por programa</a:t>
             </a:r>
           </a:p>
@@ -6704,7 +11217,7 @@
         <p:spPr>
           <a:xfrm>
             <a:off x="8028431" y="1975104"/>
-            <a:ext cx="3520440" cy="1042415"/>
+            <a:ext cx="3520439" cy="1042415"/>
           </a:xfrm>
           <a:prstGeom prst="rect">
             <a:avLst/>
@@ -6794,7 +11307,7 @@
       </p:sp>
       <p:pic>
         <p:nvPicPr>
-          <p:cNvPr id="15" name="Picture 14" descr="trending-up-blanco.png"/>
+          <p:cNvPr id="15" name="Picture 14" descr="banknote-blanco.png"/>
           <p:cNvPicPr>
             <a:picLocks noChangeAspect="1"/>
           </p:cNvPicPr>
@@ -6825,7 +11338,7 @@
         <p:spPr>
           <a:xfrm>
             <a:off x="8028431" y="3438144"/>
-            <a:ext cx="3520440" cy="1042415"/>
+            <a:ext cx="3520439" cy="1042415"/>
           </a:xfrm>
           <a:prstGeom prst="rect">
             <a:avLst/>
@@ -6846,7 +11359,7 @@
                 </a:solidFill>
                 <a:latin typeface="Calibri"/>
               </a:rPr>
-              <a:t>El presupuesto 2026 asciende a USD 1.011,2 millones y el presupuesto acumulado 2023–2026 alcanza USD 3.759,0 millones.</a:t>
+              <a:t>Bono de Desarrollo Humano registra el 26,7 % del presupuesto ejecutado 2026, con USD 270,2 millones.</a:t>
             </a:r>
           </a:p>
         </p:txBody>
@@ -6915,7 +11428,7 @@
       </p:sp>
       <p:pic>
         <p:nvPicPr>
-          <p:cNvPr id="19" name="Picture 18" descr="banknote-blanco.png"/>
+          <p:cNvPr id="19" name="Picture 18" descr="landmark-blanco.png"/>
           <p:cNvPicPr>
             <a:picLocks noChangeAspect="1"/>
           </p:cNvPicPr>
@@ -6946,7 +11459,7 @@
         <p:spPr>
           <a:xfrm>
             <a:off x="8028431" y="4901184"/>
-            <a:ext cx="3520440" cy="1042415"/>
+            <a:ext cx="3520439" cy="1042415"/>
           </a:xfrm>
           <a:prstGeom prst="rect">
             <a:avLst/>
@@ -6967,7 +11480,7 @@
                 </a:solidFill>
                 <a:latin typeface="Calibri"/>
               </a:rPr>
-              <a:t>Bono de Desarrollo Humano recibe el 26,7 % del presupuesto 2026, con USD 270,2 millones.</a:t>
+              <a:t>Guayaquil es el cantón con más beneficiarios: 133.941, el 8,5 % del país.</a:t>
             </a:r>
           </a:p>
         </p:txBody>
@@ -7002,7 +11515,7 @@
                 </a:solidFill>
                 <a:latin typeface="Calibri"/>
               </a:rPr>
-              <a:t>Fuente: Ministerio de Trabajo y Desarrollo Humano · 22 de octubre de 2026</a:t>
+              <a:t>Fuente: Ministerio de Trabajo y Desarrollo Humano · 23 de octubre de 2026</a:t>
             </a:r>
           </a:p>
         </p:txBody>
@@ -7037,7 +11550,7 @@
                 </a:solidFill>
                 <a:latin typeface="Calibri"/>
               </a:rPr>
-              <a:t>3 / 3</a:t>
+              <a:t>6 / 6</a:t>
             </a:r>
           </a:p>
         </p:txBody>

</xml_diff>